<commit_message>
Make slide 1 concrete: project, topic decision and team roles
Slide 1 now shows the competition project (unit-modular, user-customised
remodelling method with automatic module/material quantity take-off and
the app-idea demo video), how the topic conflict was resolved, and each
member's role (leader: overall lead and Dynamo automation; A: module
design and layout; B: Revit modelling and data; C: scenarios and demo
video). HTML, PDF, previews and PPTX rebuilt.

Co-Authored-By: Claude Opus 5.5 <noreply@anthropic.com>
Claude-Session: https://claude.ai/code/session_01D2YY6No1o1YF3BX8eJSF6k
</commit_message>
<xml_diff>
--- a/hec-pt/pptx/portrait.pptx
+++ b/hec-pt/pptx/portrait.pptx
@@ -1177,9 +1177,124 @@
           </a:prstGeom>
         </p:spPr>
       </p:pic>
+      <p:sp>
+        <p:nvSpPr>
+          <p:cNvPr id="8" name="p1p-proj"/>
+          <p:cNvSpPr/>
+          <p:nvPr/>
+        </p:nvSpPr>
+        <p:spPr>
+          <a:xfrm>
+            <a:off x="518160" y="2102739"/>
+            <a:ext cx="6522720" cy="1747076"/>
+          </a:xfrm>
+          <a:prstGeom prst="roundRect">
+            <a:avLst>
+              <a:gd name="adj" fmla="val 7327"/>
+            </a:avLst>
+          </a:prstGeom>
+          <a:solidFill>
+            <a:srgbClr val="FFFFFF"/>
+          </a:solidFill>
+          <a:ln w="12192">
+            <a:solidFill>
+              <a:srgbClr val="D8E0EB"/>
+            </a:solidFill>
+            <a:prstDash val="solid"/>
+          </a:ln>
+        </p:spPr>
+      </p:sp>
+      <p:sp>
+        <p:nvSpPr>
+          <p:cNvPr id="9" name="p1p-tag tech"/>
+          <p:cNvSpPr/>
+          <p:nvPr/>
+        </p:nvSpPr>
+        <p:spPr>
+          <a:xfrm>
+            <a:off x="1499807" y="2230755"/>
+            <a:ext cx="1023176" cy="207264"/>
+          </a:xfrm>
+          <a:prstGeom prst="roundRect">
+            <a:avLst>
+              <a:gd name="adj" fmla="val 50000"/>
+            </a:avLst>
+          </a:prstGeom>
+          <a:solidFill>
+            <a:srgbClr val="EEF4FC"/>
+          </a:solidFill>
+          <a:ln/>
+        </p:spPr>
+      </p:sp>
+      <p:sp>
+        <p:nvSpPr>
+          <p:cNvPr id="10" name="p1p-tag people"/>
+          <p:cNvSpPr/>
+          <p:nvPr/>
+        </p:nvSpPr>
+        <p:spPr>
+          <a:xfrm>
+            <a:off x="2583942" y="2230755"/>
+            <a:ext cx="468916" cy="207264"/>
+          </a:xfrm>
+          <a:prstGeom prst="roundRect">
+            <a:avLst>
+              <a:gd name="adj" fmla="val 50000"/>
+            </a:avLst>
+          </a:prstGeom>
+          <a:solidFill>
+            <a:srgbClr val="E5F6EC"/>
+          </a:solidFill>
+          <a:ln/>
+        </p:spPr>
+      </p:sp>
+      <p:sp>
+        <p:nvSpPr>
+          <p:cNvPr id="11" name="p1p-tag people"/>
+          <p:cNvSpPr/>
+          <p:nvPr/>
+        </p:nvSpPr>
+        <p:spPr>
+          <a:xfrm>
+            <a:off x="3113818" y="2230755"/>
+            <a:ext cx="373856" cy="207264"/>
+          </a:xfrm>
+          <a:prstGeom prst="roundRect">
+            <a:avLst>
+              <a:gd name="adj" fmla="val 50000"/>
+            </a:avLst>
+          </a:prstGeom>
+          <a:solidFill>
+            <a:srgbClr val="E5F6EC"/>
+          </a:solidFill>
+          <a:ln/>
+        </p:spPr>
+      </p:sp>
+      <p:sp>
+        <p:nvSpPr>
+          <p:cNvPr id="12" name="p1p-out"/>
+          <p:cNvSpPr/>
+          <p:nvPr/>
+        </p:nvSpPr>
+        <p:spPr>
+          <a:xfrm>
+            <a:off x="5120640" y="2218563"/>
+            <a:ext cx="1804416" cy="975360"/>
+          </a:xfrm>
+          <a:prstGeom prst="roundRect">
+            <a:avLst>
+              <a:gd name="adj" fmla="val 10000"/>
+            </a:avLst>
+          </a:prstGeom>
+          <a:solidFill>
+            <a:srgbClr val="FFF4DB"/>
+          </a:solidFill>
+          <a:ln/>
+        </p:spPr>
+      </p:sp>
       <p:pic>
         <p:nvPicPr>
-          <p:cNvPr id="8" name="p1p-path" descr="p1p-path">    </p:cNvPr>
+          <p:cNvPr id="13" name="svg" descr="svg">    </p:cNvPr>
           <p:cNvPicPr>
             <a:picLocks noChangeAspect="1"/>
           </p:cNvPicPr>
@@ -1193,8 +1308,8 @@
         </p:blipFill>
         <p:spPr>
           <a:xfrm>
-            <a:off x="1136904" y="2242947"/>
-            <a:ext cx="22352" cy="6961632"/>
+            <a:off x="5242560" y="2333816"/>
+            <a:ext cx="158496" cy="158496"/>
           </a:xfrm>
           <a:prstGeom prst="rect">
             <a:avLst/>
@@ -1203,34 +1318,27 @@
       </p:pic>
       <p:sp>
         <p:nvSpPr>
-          <p:cNvPr id="9" name="span"/>
+          <p:cNvPr id="14" name="p1p-proj-bot"/>
           <p:cNvSpPr/>
           <p:nvPr/>
         </p:nvSpPr>
         <p:spPr>
           <a:xfrm>
-            <a:off x="707041" y="2108835"/>
-            <a:ext cx="878015" cy="268224"/>
-          </a:xfrm>
-          <a:prstGeom prst="roundRect">
-            <a:avLst>
-              <a:gd name="adj" fmla="val 50000"/>
-            </a:avLst>
-          </a:prstGeom>
-          <a:solidFill>
-            <a:srgbClr val="FFFFFF"/>
-          </a:solidFill>
-          <a:ln w="12192">
-            <a:solidFill>
-              <a:srgbClr val="C3CEDD"/>
-            </a:solidFill>
-            <a:prstDash val="solid"/>
-          </a:ln>
+            <a:off x="524256" y="3303651"/>
+            <a:ext cx="6510528" cy="540068"/>
+          </a:xfrm>
+          <a:prstGeom prst="rect">
+            <a:avLst/>
+          </a:prstGeom>
+          <a:solidFill>
+            <a:srgbClr val="EEF4FC"/>
+          </a:solidFill>
+          <a:ln/>
         </p:spPr>
       </p:sp>
       <p:pic>
         <p:nvPicPr>
-          <p:cNvPr id="10" name="svg" descr="svg">    </p:cNvPr>
+          <p:cNvPr id="15" name="ring p1p-fr" descr="ring p1p-fr">    </p:cNvPr>
           <p:cNvPicPr>
             <a:picLocks noChangeAspect="1"/>
           </p:cNvPicPr>
@@ -1244,85 +1352,17 @@
         </p:blipFill>
         <p:spPr>
           <a:xfrm>
-            <a:off x="824897" y="2196211"/>
-            <a:ext cx="93472" cy="93472"/>
+            <a:off x="731520" y="3407061"/>
+            <a:ext cx="316992" cy="316992"/>
           </a:xfrm>
           <a:prstGeom prst="rect">
             <a:avLst/>
           </a:prstGeom>
         </p:spPr>
       </p:pic>
-      <p:sp>
-        <p:nvSpPr>
-          <p:cNvPr id="11" name="chip tech"/>
-          <p:cNvSpPr/>
-          <p:nvPr/>
-        </p:nvSpPr>
-        <p:spPr>
-          <a:xfrm>
-            <a:off x="3158585" y="2102739"/>
-            <a:ext cx="1238250" cy="280416"/>
-          </a:xfrm>
-          <a:prstGeom prst="roundRect">
-            <a:avLst>
-              <a:gd name="adj" fmla="val 50000"/>
-            </a:avLst>
-          </a:prstGeom>
-          <a:solidFill>
-            <a:srgbClr val="EEF4FC"/>
-          </a:solidFill>
-          <a:ln/>
-        </p:spPr>
-      </p:sp>
-      <p:sp>
-        <p:nvSpPr>
-          <p:cNvPr id="12" name="chip people"/>
-          <p:cNvSpPr/>
-          <p:nvPr/>
-        </p:nvSpPr>
-        <p:spPr>
-          <a:xfrm>
-            <a:off x="4469987" y="2102739"/>
-            <a:ext cx="836200" cy="280416"/>
-          </a:xfrm>
-          <a:prstGeom prst="roundRect">
-            <a:avLst>
-              <a:gd name="adj" fmla="val 50000"/>
-            </a:avLst>
-          </a:prstGeom>
-          <a:solidFill>
-            <a:srgbClr val="E5F6EC"/>
-          </a:solidFill>
-          <a:ln/>
-        </p:spPr>
-      </p:sp>
-      <p:sp>
-        <p:nvSpPr>
-          <p:cNvPr id="13" name="chip ghost"/>
-          <p:cNvSpPr/>
-          <p:nvPr/>
-        </p:nvSpPr>
-        <p:spPr>
-          <a:xfrm>
-            <a:off x="5385435" y="2108835"/>
-            <a:ext cx="847535" cy="268224"/>
-          </a:xfrm>
-          <a:prstGeom prst="roundRect">
-            <a:avLst>
-              <a:gd name="adj" fmla="val 50000"/>
-            </a:avLst>
-          </a:prstGeom>
-          <a:ln w="12192">
-            <a:solidFill>
-              <a:srgbClr val="D8E0EB"/>
-            </a:solidFill>
-            <a:prstDash val="solid"/>
-          </a:ln>
-        </p:spPr>
-      </p:sp>
       <p:pic>
         <p:nvPicPr>
-          <p:cNvPr id="14" name="svg" descr="svg">    </p:cNvPr>
+          <p:cNvPr id="16" name="svg" descr="svg">    </p:cNvPr>
           <p:cNvPicPr>
             <a:picLocks noChangeAspect="1"/>
           </p:cNvPicPr>
@@ -1336,37 +1376,17 @@
         </p:blipFill>
         <p:spPr>
           <a:xfrm>
-            <a:off x="512064" y="2591213"/>
-            <a:ext cx="1267968" cy="1267968"/>
+            <a:off x="827024" y="3502565"/>
+            <a:ext cx="125984" cy="138176"/>
           </a:xfrm>
           <a:prstGeom prst="rect">
             <a:avLst/>
           </a:prstGeom>
         </p:spPr>
       </p:pic>
-      <p:sp>
-        <p:nvSpPr>
-          <p:cNvPr id="15" name="s"/>
-          <p:cNvSpPr/>
-          <p:nvPr/>
-        </p:nvSpPr>
-        <p:spPr>
-          <a:xfrm>
-            <a:off x="2252186" y="2817495"/>
-            <a:ext cx="134112" cy="12192"/>
-          </a:xfrm>
-          <a:prstGeom prst="rect">
-            <a:avLst/>
-          </a:prstGeom>
-          <a:solidFill>
-            <a:srgbClr val="C3CEDD"/>
-          </a:solidFill>
-          <a:ln/>
-        </p:spPr>
-      </p:sp>
       <p:pic>
         <p:nvPicPr>
-          <p:cNvPr id="16" name="li" descr="li">    </p:cNvPr>
+          <p:cNvPr id="17" name="p1p-fc" descr="p1p-fc">    </p:cNvPr>
           <p:cNvPicPr>
             <a:picLocks noChangeAspect="1"/>
           </p:cNvPicPr>
@@ -1380,8 +1400,8 @@
         </p:blipFill>
         <p:spPr>
           <a:xfrm>
-            <a:off x="2023872" y="3273520"/>
-            <a:ext cx="2474976" cy="426720"/>
+            <a:off x="1662525" y="3523901"/>
+            <a:ext cx="1349248" cy="85344"/>
           </a:xfrm>
           <a:prstGeom prst="rect">
             <a:avLst/>
@@ -1390,7 +1410,7 @@
       </p:pic>
       <p:pic>
         <p:nvPicPr>
-          <p:cNvPr id="17" name="li" descr="li">    </p:cNvPr>
+          <p:cNvPr id="18" name="ring p1p-fr" descr="ring p1p-fr">    </p:cNvPr>
           <p:cNvPicPr>
             <a:picLocks noChangeAspect="1"/>
           </p:cNvPicPr>
@@ -1404,8 +1424,8 @@
         </p:blipFill>
         <p:spPr>
           <a:xfrm>
-            <a:off x="4572000" y="3273520"/>
-            <a:ext cx="2474976" cy="426720"/>
+            <a:off x="3083846" y="3407061"/>
+            <a:ext cx="316992" cy="316992"/>
           </a:xfrm>
           <a:prstGeom prst="rect">
             <a:avLst/>
@@ -1414,7 +1434,7 @@
       </p:pic>
       <p:pic>
         <p:nvPicPr>
-          <p:cNvPr id="18" name="i" descr="i">    </p:cNvPr>
+          <p:cNvPr id="19" name="svg" descr="svg">    </p:cNvPr>
           <p:cNvPicPr>
             <a:picLocks noChangeAspect="1"/>
           </p:cNvPicPr>
@@ -1428,8 +1448,8 @@
         </p:blipFill>
         <p:spPr>
           <a:xfrm>
-            <a:off x="1091184" y="4004247"/>
-            <a:ext cx="109728" cy="109728"/>
+            <a:off x="3175286" y="3498501"/>
+            <a:ext cx="134112" cy="134112"/>
           </a:xfrm>
           <a:prstGeom prst="rect">
             <a:avLst/>
@@ -1438,7 +1458,7 @@
       </p:pic>
       <p:pic>
         <p:nvPicPr>
-          <p:cNvPr id="19" name="svg" descr="svg">    </p:cNvPr>
+          <p:cNvPr id="20" name="p1p-fc" descr="p1p-fc">    </p:cNvPr>
           <p:cNvPicPr>
             <a:picLocks noChangeAspect="1"/>
           </p:cNvPicPr>
@@ -1452,37 +1472,17 @@
         </p:blipFill>
         <p:spPr>
           <a:xfrm>
-            <a:off x="512064" y="4254976"/>
-            <a:ext cx="1267968" cy="1267968"/>
+            <a:off x="4125754" y="3523901"/>
+            <a:ext cx="1343152" cy="85344"/>
           </a:xfrm>
           <a:prstGeom prst="rect">
             <a:avLst/>
           </a:prstGeom>
         </p:spPr>
       </p:pic>
-      <p:sp>
-        <p:nvSpPr>
-          <p:cNvPr id="20" name="s"/>
-          <p:cNvSpPr/>
-          <p:nvPr/>
-        </p:nvSpPr>
-        <p:spPr>
-          <a:xfrm>
-            <a:off x="2252186" y="4485323"/>
-            <a:ext cx="134112" cy="12192"/>
-          </a:xfrm>
-          <a:prstGeom prst="rect">
-            <a:avLst/>
-          </a:prstGeom>
-          <a:solidFill>
-            <a:srgbClr val="C3CEDD"/>
-          </a:solidFill>
-          <a:ln/>
-        </p:spPr>
-      </p:sp>
       <p:pic>
         <p:nvPicPr>
-          <p:cNvPr id="21" name="li" descr="li">    </p:cNvPr>
+          <p:cNvPr id="21" name="ring solid p1p-fr" descr="ring solid p1p-fr">    </p:cNvPr>
           <p:cNvPicPr>
             <a:picLocks noChangeAspect="1"/>
           </p:cNvPicPr>
@@ -1496,8 +1496,8 @@
         </p:blipFill>
         <p:spPr>
           <a:xfrm>
-            <a:off x="2023872" y="4943380"/>
-            <a:ext cx="2474976" cy="426720"/>
+            <a:off x="5540978" y="3407061"/>
+            <a:ext cx="316992" cy="316992"/>
           </a:xfrm>
           <a:prstGeom prst="rect">
             <a:avLst/>
@@ -1506,7 +1506,7 @@
       </p:pic>
       <p:pic>
         <p:nvPicPr>
-          <p:cNvPr id="22" name="li" descr="li">    </p:cNvPr>
+          <p:cNvPr id="22" name="svg" descr="svg">    </p:cNvPr>
           <p:cNvPicPr>
             <a:picLocks noChangeAspect="1"/>
           </p:cNvPicPr>
@@ -1520,8 +1520,8 @@
         </p:blipFill>
         <p:spPr>
           <a:xfrm>
-            <a:off x="4572000" y="4943380"/>
-            <a:ext cx="2474976" cy="426720"/>
+            <a:off x="5642578" y="3508661"/>
+            <a:ext cx="113792" cy="113792"/>
           </a:xfrm>
           <a:prstGeom prst="rect">
             <a:avLst/>
@@ -1530,7 +1530,7 @@
       </p:pic>
       <p:pic>
         <p:nvPicPr>
-          <p:cNvPr id="23" name="i" descr="i">    </p:cNvPr>
+          <p:cNvPr id="23" name="p1p-path" descr="p1p-path">    </p:cNvPr>
           <p:cNvPicPr>
             <a:picLocks noChangeAspect="1"/>
           </p:cNvPicPr>
@@ -1544,17 +1544,42 @@
         </p:blipFill>
         <p:spPr>
           <a:xfrm>
-            <a:off x="1091184" y="5670042"/>
-            <a:ext cx="109728" cy="109728"/>
+            <a:off x="893064" y="3857943"/>
+            <a:ext cx="22352" cy="5163312"/>
           </a:xfrm>
           <a:prstGeom prst="rect">
             <a:avLst/>
           </a:prstGeom>
         </p:spPr>
       </p:pic>
+      <p:sp>
+        <p:nvSpPr>
+          <p:cNvPr id="24" name="p1p-top"/>
+          <p:cNvSpPr/>
+          <p:nvPr/>
+        </p:nvSpPr>
+        <p:spPr>
+          <a:xfrm>
+            <a:off x="862584" y="3810191"/>
+            <a:ext cx="79248" cy="79248"/>
+          </a:xfrm>
+          <a:prstGeom prst="ellipse">
+            <a:avLst/>
+          </a:prstGeom>
+          <a:solidFill>
+            <a:srgbClr val="45B9EC"/>
+          </a:solidFill>
+          <a:ln w="18288">
+            <a:solidFill>
+              <a:srgbClr val="FFFFFF"/>
+            </a:solidFill>
+            <a:prstDash val="solid"/>
+          </a:ln>
+        </p:spPr>
+      </p:sp>
       <p:pic>
         <p:nvPicPr>
-          <p:cNvPr id="24" name="svg" descr="svg">    </p:cNvPr>
+          <p:cNvPr id="25" name="svg" descr="svg">    </p:cNvPr>
           <p:cNvPicPr>
             <a:picLocks noChangeAspect="1"/>
           </p:cNvPicPr>
@@ -1568,8 +1593,8 @@
         </p:blipFill>
         <p:spPr>
           <a:xfrm>
-            <a:off x="512064" y="5924836"/>
-            <a:ext cx="1267968" cy="1267968"/>
+            <a:off x="510032" y="4016439"/>
+            <a:ext cx="782320" cy="780288"/>
           </a:xfrm>
           <a:prstGeom prst="rect">
             <a:avLst/>
@@ -1578,13 +1603,13 @@
       </p:pic>
       <p:sp>
         <p:nvSpPr>
-          <p:cNvPr id="25" name="s"/>
+          <p:cNvPr id="26" name="s"/>
           <p:cNvSpPr/>
           <p:nvPr/>
         </p:nvSpPr>
         <p:spPr>
           <a:xfrm>
-            <a:off x="2252186" y="6153150"/>
+            <a:off x="1727930" y="4108609"/>
             <a:ext cx="134112" cy="12192"/>
           </a:xfrm>
           <a:prstGeom prst="rect">
@@ -1598,7 +1623,7 @@
       </p:sp>
       <p:pic>
         <p:nvPicPr>
-          <p:cNvPr id="26" name="li" descr="li">    </p:cNvPr>
+          <p:cNvPr id="27" name="p1p-fact" descr="p1p-fact">    </p:cNvPr>
           <p:cNvPicPr>
             <a:picLocks noChangeAspect="1"/>
           </p:cNvPicPr>
@@ -1612,17 +1637,41 @@
         </p:blipFill>
         <p:spPr>
           <a:xfrm>
-            <a:off x="2023872" y="6613239"/>
-            <a:ext cx="2474976" cy="426720"/>
+            <a:off x="1499616" y="4493514"/>
+            <a:ext cx="1444752" cy="280416"/>
           </a:xfrm>
           <a:prstGeom prst="rect">
             <a:avLst/>
           </a:prstGeom>
         </p:spPr>
       </p:pic>
+      <p:sp>
+        <p:nvSpPr>
+          <p:cNvPr id="28" name="p1p-fact ic"/>
+          <p:cNvSpPr/>
+          <p:nvPr/>
+        </p:nvSpPr>
+        <p:spPr>
+          <a:xfrm>
+            <a:off x="3013996" y="4499610"/>
+            <a:ext cx="1822990" cy="268224"/>
+          </a:xfrm>
+          <a:prstGeom prst="roundRect">
+            <a:avLst>
+              <a:gd name="adj" fmla="val 50000"/>
+            </a:avLst>
+          </a:prstGeom>
+          <a:ln w="12192">
+            <a:solidFill>
+              <a:srgbClr val="D8E0EB"/>
+            </a:solidFill>
+            <a:prstDash val="solid"/>
+          </a:ln>
+        </p:spPr>
+      </p:sp>
       <p:pic>
         <p:nvPicPr>
-          <p:cNvPr id="27" name="li" descr="li">    </p:cNvPr>
+          <p:cNvPr id="29" name="svg" descr="svg">    </p:cNvPr>
           <p:cNvPicPr>
             <a:picLocks noChangeAspect="1"/>
           </p:cNvPicPr>
@@ -1636,17 +1685,42 @@
         </p:blipFill>
         <p:spPr>
           <a:xfrm>
-            <a:off x="4572000" y="6613239"/>
-            <a:ext cx="2474976" cy="426720"/>
+            <a:off x="3142012" y="4580890"/>
+            <a:ext cx="105664" cy="105664"/>
           </a:xfrm>
           <a:prstGeom prst="rect">
             <a:avLst/>
           </a:prstGeom>
         </p:spPr>
       </p:pic>
+      <p:sp>
+        <p:nvSpPr>
+          <p:cNvPr id="30" name="i"/>
+          <p:cNvSpPr/>
+          <p:nvPr/>
+        </p:nvSpPr>
+        <p:spPr>
+          <a:xfrm>
+            <a:off x="862584" y="4850606"/>
+            <a:ext cx="79248" cy="79248"/>
+          </a:xfrm>
+          <a:prstGeom prst="ellipse">
+            <a:avLst/>
+          </a:prstGeom>
+          <a:solidFill>
+            <a:srgbClr val="3DA6E7"/>
+          </a:solidFill>
+          <a:ln w="18288">
+            <a:solidFill>
+              <a:srgbClr val="FFFFFF"/>
+            </a:solidFill>
+            <a:prstDash val="solid"/>
+          </a:ln>
+        </p:spPr>
+      </p:sp>
       <p:pic>
         <p:nvPicPr>
-          <p:cNvPr id="28" name="i" descr="i">    </p:cNvPr>
+          <p:cNvPr id="31" name="svg" descr="svg">    </p:cNvPr>
           <p:cNvPicPr>
             <a:picLocks noChangeAspect="1"/>
           </p:cNvPicPr>
@@ -1660,17 +1734,37 @@
         </p:blipFill>
         <p:spPr>
           <a:xfrm>
-            <a:off x="1091184" y="7339902"/>
-            <a:ext cx="109728" cy="109728"/>
+            <a:off x="512064" y="4985766"/>
+            <a:ext cx="780288" cy="780288"/>
           </a:xfrm>
           <a:prstGeom prst="rect">
             <a:avLst/>
           </a:prstGeom>
         </p:spPr>
       </p:pic>
+      <p:sp>
+        <p:nvSpPr>
+          <p:cNvPr id="32" name="s"/>
+          <p:cNvSpPr/>
+          <p:nvPr/>
+        </p:nvSpPr>
+        <p:spPr>
+          <a:xfrm>
+            <a:off x="1727930" y="5079968"/>
+            <a:ext cx="134112" cy="12192"/>
+          </a:xfrm>
+          <a:prstGeom prst="rect">
+            <a:avLst/>
+          </a:prstGeom>
+          <a:solidFill>
+            <a:srgbClr val="C3CEDD"/>
+          </a:solidFill>
+          <a:ln/>
+        </p:spPr>
+      </p:sp>
       <p:pic>
         <p:nvPicPr>
-          <p:cNvPr id="29" name="svg" descr="svg">    </p:cNvPr>
+          <p:cNvPr id="33" name="p1p-fact" descr="p1p-fact">    </p:cNvPr>
           <p:cNvPicPr>
             <a:picLocks noChangeAspect="1"/>
           </p:cNvPicPr>
@@ -1684,37 +1778,17 @@
         </p:blipFill>
         <p:spPr>
           <a:xfrm>
-            <a:off x="512064" y="7594695"/>
-            <a:ext cx="1267968" cy="1267968"/>
+            <a:off x="1499616" y="5462842"/>
+            <a:ext cx="1932432" cy="280416"/>
           </a:xfrm>
           <a:prstGeom prst="rect">
             <a:avLst/>
           </a:prstGeom>
         </p:spPr>
       </p:pic>
-      <p:sp>
-        <p:nvSpPr>
-          <p:cNvPr id="30" name="s"/>
-          <p:cNvSpPr/>
-          <p:nvPr/>
-        </p:nvSpPr>
-        <p:spPr>
-          <a:xfrm>
-            <a:off x="2252186" y="7820978"/>
-            <a:ext cx="134112" cy="12192"/>
-          </a:xfrm>
-          <a:prstGeom prst="rect">
-            <a:avLst/>
-          </a:prstGeom>
-          <a:solidFill>
-            <a:srgbClr val="C3CEDD"/>
-          </a:solidFill>
-          <a:ln/>
-        </p:spPr>
-      </p:sp>
       <p:pic>
         <p:nvPicPr>
-          <p:cNvPr id="31" name="li" descr="li">    </p:cNvPr>
+          <p:cNvPr id="34" name="p1p-to" descr="p1p-to">    </p:cNvPr>
           <p:cNvPicPr>
             <a:picLocks noChangeAspect="1"/>
           </p:cNvPicPr>
@@ -1728,8 +1802,8 @@
         </p:blipFill>
         <p:spPr>
           <a:xfrm>
-            <a:off x="2023872" y="8279035"/>
-            <a:ext cx="2474976" cy="426720"/>
+            <a:off x="3491357" y="5570538"/>
+            <a:ext cx="83312" cy="65024"/>
           </a:xfrm>
           <a:prstGeom prst="rect">
             <a:avLst/>
@@ -1738,7 +1812,7 @@
       </p:pic>
       <p:pic>
         <p:nvPicPr>
-          <p:cNvPr id="32" name="li" descr="li">    </p:cNvPr>
+          <p:cNvPr id="35" name="p1p-fact" descr="p1p-fact">    </p:cNvPr>
           <p:cNvPicPr>
             <a:picLocks noChangeAspect="1"/>
           </p:cNvPicPr>
@@ -1752,44 +1826,17 @@
         </p:blipFill>
         <p:spPr>
           <a:xfrm>
-            <a:off x="4572000" y="8279035"/>
-            <a:ext cx="2474976" cy="426720"/>
+            <a:off x="3639693" y="5462842"/>
+            <a:ext cx="1097280" cy="280416"/>
           </a:xfrm>
           <a:prstGeom prst="rect">
             <a:avLst/>
           </a:prstGeom>
         </p:spPr>
       </p:pic>
-      <p:sp>
-        <p:nvSpPr>
-          <p:cNvPr id="33" name="span"/>
-          <p:cNvSpPr/>
-          <p:nvPr/>
-        </p:nvSpPr>
-        <p:spPr>
-          <a:xfrm>
-            <a:off x="707041" y="9072753"/>
-            <a:ext cx="878015" cy="268224"/>
-          </a:xfrm>
-          <a:prstGeom prst="roundRect">
-            <a:avLst>
-              <a:gd name="adj" fmla="val 50000"/>
-            </a:avLst>
-          </a:prstGeom>
-          <a:solidFill>
-            <a:srgbClr val="FFF4DB"/>
-          </a:solidFill>
-          <a:ln w="12192">
-            <a:solidFill>
-              <a:srgbClr val="FFF4DB"/>
-            </a:solidFill>
-            <a:prstDash val="solid"/>
-          </a:ln>
-        </p:spPr>
-      </p:sp>
       <p:pic>
         <p:nvPicPr>
-          <p:cNvPr id="34" name="svg" descr="svg">    </p:cNvPr>
+          <p:cNvPr id="36" name="p1p-to" descr="p1p-to">    </p:cNvPr>
           <p:cNvPicPr>
             <a:picLocks noChangeAspect="1"/>
           </p:cNvPicPr>
@@ -1803,17 +1850,697 @@
         </p:blipFill>
         <p:spPr>
           <a:xfrm>
-            <a:off x="828961" y="9162161"/>
-            <a:ext cx="85344" cy="85344"/>
+            <a:off x="4796504" y="5570538"/>
+            <a:ext cx="83312" cy="65024"/>
           </a:xfrm>
           <a:prstGeom prst="rect">
             <a:avLst/>
           </a:prstGeom>
         </p:spPr>
       </p:pic>
-      <p:sp>
-        <p:nvSpPr>
-          <p:cNvPr id="35" name="key"/>
+      <p:pic>
+        <p:nvPicPr>
+          <p:cNvPr id="37" name="p1p-fact key2" descr="p1p-fact key2">    </p:cNvPr>
+          <p:cNvPicPr>
+            <a:picLocks noChangeAspect="1"/>
+          </p:cNvPicPr>
+          <p:nvPr/>
+        </p:nvPicPr>
+        <p:blipFill>
+          <a:blip r:embed="rId20"/>
+          <a:stretch>
+            <a:fillRect/>
+          </a:stretch>
+        </p:blipFill>
+        <p:spPr>
+          <a:xfrm>
+            <a:off x="4944840" y="5462842"/>
+            <a:ext cx="847344" cy="280416"/>
+          </a:xfrm>
+          <a:prstGeom prst="rect">
+            <a:avLst/>
+          </a:prstGeom>
+        </p:spPr>
+      </p:pic>
+      <p:sp>
+        <p:nvSpPr>
+          <p:cNvPr id="38" name="i"/>
+          <p:cNvSpPr/>
+          <p:nvPr/>
+        </p:nvSpPr>
+        <p:spPr>
+          <a:xfrm>
+            <a:off x="862584" y="5821966"/>
+            <a:ext cx="79248" cy="79248"/>
+          </a:xfrm>
+          <a:prstGeom prst="ellipse">
+            <a:avLst/>
+          </a:prstGeom>
+          <a:solidFill>
+            <a:srgbClr val="3695E4"/>
+          </a:solidFill>
+          <a:ln w="18288">
+            <a:solidFill>
+              <a:srgbClr val="FFFFFF"/>
+            </a:solidFill>
+            <a:prstDash val="solid"/>
+          </a:ln>
+        </p:spPr>
+      </p:sp>
+      <p:sp>
+        <p:nvSpPr>
+          <p:cNvPr id="39" name="s"/>
+          <p:cNvSpPr/>
+          <p:nvPr/>
+        </p:nvSpPr>
+        <p:spPr>
+          <a:xfrm>
+            <a:off x="1727930" y="6030563"/>
+            <a:ext cx="134112" cy="12192"/>
+          </a:xfrm>
+          <a:prstGeom prst="rect">
+            <a:avLst/>
+          </a:prstGeom>
+          <a:solidFill>
+            <a:srgbClr val="C3CEDD"/>
+          </a:solidFill>
+          <a:ln/>
+        </p:spPr>
+      </p:sp>
+      <p:pic>
+        <p:nvPicPr>
+          <p:cNvPr id="40" name="svg" descr="svg">    </p:cNvPr>
+          <p:cNvPicPr>
+            <a:picLocks noChangeAspect="1"/>
+          </p:cNvPicPr>
+          <p:nvPr/>
+        </p:nvPicPr>
+        <p:blipFill>
+          <a:blip r:embed="rId21"/>
+          <a:stretch>
+            <a:fillRect/>
+          </a:stretch>
+        </p:blipFill>
+        <p:spPr>
+          <a:xfrm>
+            <a:off x="512064" y="7046913"/>
+            <a:ext cx="780288" cy="780288"/>
+          </a:xfrm>
+          <a:prstGeom prst="rect">
+            <a:avLst/>
+          </a:prstGeom>
+        </p:spPr>
+      </p:pic>
+      <p:sp>
+        <p:nvSpPr>
+          <p:cNvPr id="41" name="p1p-role me"/>
+          <p:cNvSpPr/>
+          <p:nvPr/>
+        </p:nvSpPr>
+        <p:spPr>
+          <a:xfrm>
+            <a:off x="1505712" y="6433757"/>
+            <a:ext cx="2712720" cy="836676"/>
+          </a:xfrm>
+          <a:prstGeom prst="roundRect">
+            <a:avLst>
+              <a:gd name="adj" fmla="val 12386"/>
+            </a:avLst>
+          </a:prstGeom>
+          <a:solidFill>
+            <a:srgbClr val="FFFFFF"/>
+          </a:solidFill>
+          <a:ln w="12192">
+            <a:solidFill>
+              <a:srgbClr val="004B8D"/>
+            </a:solidFill>
+            <a:prstDash val="solid"/>
+          </a:ln>
+        </p:spPr>
+      </p:sp>
+      <p:pic>
+        <p:nvPicPr>
+          <p:cNvPr id="42" name="svg" descr="svg">    </p:cNvPr>
+          <p:cNvPicPr>
+            <a:picLocks noChangeAspect="1"/>
+          </p:cNvPicPr>
+          <p:nvPr/>
+        </p:nvPicPr>
+        <p:blipFill>
+          <a:blip r:embed="rId22"/>
+          <a:stretch>
+            <a:fillRect/>
+          </a:stretch>
+        </p:blipFill>
+        <p:spPr>
+          <a:xfrm>
+            <a:off x="1633728" y="6546279"/>
+            <a:ext cx="182880" cy="182880"/>
+          </a:xfrm>
+          <a:prstGeom prst="rect">
+            <a:avLst/>
+          </a:prstGeom>
+        </p:spPr>
+      </p:pic>
+      <p:sp>
+        <p:nvSpPr>
+          <p:cNvPr id="43" name="p1p-me"/>
+          <p:cNvSpPr/>
+          <p:nvPr/>
+        </p:nvSpPr>
+        <p:spPr>
+          <a:xfrm>
+            <a:off x="2197608" y="6550343"/>
+            <a:ext cx="229648" cy="170688"/>
+          </a:xfrm>
+          <a:prstGeom prst="roundRect">
+            <a:avLst>
+              <a:gd name="adj" fmla="val 50000"/>
+            </a:avLst>
+          </a:prstGeom>
+          <a:solidFill>
+            <a:srgbClr val="004B8D"/>
+          </a:solidFill>
+          <a:ln/>
+        </p:spPr>
+      </p:sp>
+      <p:sp>
+        <p:nvSpPr>
+          <p:cNvPr id="44" name="p1p-tech"/>
+          <p:cNvSpPr/>
+          <p:nvPr/>
+        </p:nvSpPr>
+        <p:spPr>
+          <a:xfrm>
+            <a:off x="1633728" y="6996113"/>
+            <a:ext cx="635222" cy="182880"/>
+          </a:xfrm>
+          <a:prstGeom prst="roundRect">
+            <a:avLst>
+              <a:gd name="adj" fmla="val 50000"/>
+            </a:avLst>
+          </a:prstGeom>
+          <a:solidFill>
+            <a:srgbClr val="EEF4FC"/>
+          </a:solidFill>
+          <a:ln/>
+        </p:spPr>
+      </p:sp>
+      <p:sp>
+        <p:nvSpPr>
+          <p:cNvPr id="45" name="p1p-role"/>
+          <p:cNvSpPr/>
+          <p:nvPr/>
+        </p:nvSpPr>
+        <p:spPr>
+          <a:xfrm>
+            <a:off x="4328160" y="6433757"/>
+            <a:ext cx="2712720" cy="836676"/>
+          </a:xfrm>
+          <a:prstGeom prst="roundRect">
+            <a:avLst>
+              <a:gd name="adj" fmla="val 12386"/>
+            </a:avLst>
+          </a:prstGeom>
+          <a:solidFill>
+            <a:srgbClr val="FFFFFF"/>
+          </a:solidFill>
+          <a:ln w="12192">
+            <a:solidFill>
+              <a:srgbClr val="D8E0EB"/>
+            </a:solidFill>
+            <a:prstDash val="solid"/>
+          </a:ln>
+        </p:spPr>
+      </p:sp>
+      <p:pic>
+        <p:nvPicPr>
+          <p:cNvPr id="46" name="svg" descr="svg">    </p:cNvPr>
+          <p:cNvPicPr>
+            <a:picLocks noChangeAspect="1"/>
+          </p:cNvPicPr>
+          <p:nvPr/>
+        </p:nvPicPr>
+        <p:blipFill>
+          <a:blip r:embed="rId23"/>
+          <a:stretch>
+            <a:fillRect/>
+          </a:stretch>
+        </p:blipFill>
+        <p:spPr>
+          <a:xfrm>
+            <a:off x="4456176" y="6546279"/>
+            <a:ext cx="182880" cy="182880"/>
+          </a:xfrm>
+          <a:prstGeom prst="rect">
+            <a:avLst/>
+          </a:prstGeom>
+        </p:spPr>
+      </p:pic>
+      <p:pic>
+        <p:nvPicPr>
+          <p:cNvPr id="47" name="p1p-hub-ln" descr="p1p-hub-ln">    </p:cNvPr>
+          <p:cNvPicPr>
+            <a:picLocks noChangeAspect="1"/>
+          </p:cNvPicPr>
+          <p:nvPr/>
+        </p:nvPicPr>
+        <p:blipFill>
+          <a:blip r:embed="rId24"/>
+          <a:stretch>
+            <a:fillRect/>
+          </a:stretch>
+        </p:blipFill>
+        <p:spPr>
+          <a:xfrm>
+            <a:off x="1290320" y="7425881"/>
+            <a:ext cx="4399280" cy="18288"/>
+          </a:xfrm>
+          <a:prstGeom prst="rect">
+            <a:avLst/>
+          </a:prstGeom>
+        </p:spPr>
+      </p:pic>
+      <p:sp>
+        <p:nvSpPr>
+          <p:cNvPr id="48" name="p1p-share"/>
+          <p:cNvSpPr/>
+          <p:nvPr/>
+        </p:nvSpPr>
+        <p:spPr>
+          <a:xfrm>
+            <a:off x="3279839" y="7307009"/>
+            <a:ext cx="1986915" cy="256032"/>
+          </a:xfrm>
+          <a:prstGeom prst="roundRect">
+            <a:avLst>
+              <a:gd name="adj" fmla="val 50000"/>
+            </a:avLst>
+          </a:prstGeom>
+          <a:solidFill>
+            <a:srgbClr val="E5F6EC"/>
+          </a:solidFill>
+          <a:ln w="12192">
+            <a:solidFill>
+              <a:srgbClr val="FFFFFF"/>
+            </a:solidFill>
+            <a:prstDash val="solid"/>
+          </a:ln>
+        </p:spPr>
+      </p:sp>
+      <p:pic>
+        <p:nvPicPr>
+          <p:cNvPr id="49" name="svg" descr="svg">    </p:cNvPr>
+          <p:cNvPicPr>
+            <a:picLocks noChangeAspect="1"/>
+          </p:cNvPicPr>
+          <p:nvPr/>
+        </p:nvPicPr>
+        <p:blipFill>
+          <a:blip r:embed="rId25"/>
+          <a:stretch>
+            <a:fillRect/>
+          </a:stretch>
+        </p:blipFill>
+        <p:spPr>
+          <a:xfrm>
+            <a:off x="3385503" y="7382193"/>
+            <a:ext cx="105664" cy="109728"/>
+          </a:xfrm>
+          <a:prstGeom prst="rect">
+            <a:avLst/>
+          </a:prstGeom>
+        </p:spPr>
+      </p:pic>
+      <p:sp>
+        <p:nvSpPr>
+          <p:cNvPr id="50" name="p1p-role"/>
+          <p:cNvSpPr/>
+          <p:nvPr/>
+        </p:nvSpPr>
+        <p:spPr>
+          <a:xfrm>
+            <a:off x="1505712" y="7599617"/>
+            <a:ext cx="2712720" cy="836676"/>
+          </a:xfrm>
+          <a:prstGeom prst="roundRect">
+            <a:avLst>
+              <a:gd name="adj" fmla="val 12386"/>
+            </a:avLst>
+          </a:prstGeom>
+          <a:solidFill>
+            <a:srgbClr val="FFFFFF"/>
+          </a:solidFill>
+          <a:ln w="12192">
+            <a:solidFill>
+              <a:srgbClr val="D8E0EB"/>
+            </a:solidFill>
+            <a:prstDash val="solid"/>
+          </a:ln>
+        </p:spPr>
+      </p:sp>
+      <p:pic>
+        <p:nvPicPr>
+          <p:cNvPr id="51" name="p1p-hub-st l" descr="p1p-hub-st l">    </p:cNvPr>
+          <p:cNvPicPr>
+            <a:picLocks noChangeAspect="1"/>
+          </p:cNvPicPr>
+          <p:nvPr/>
+        </p:nvPicPr>
+        <p:blipFill>
+          <a:blip r:embed="rId26"/>
+          <a:stretch>
+            <a:fillRect/>
+          </a:stretch>
+        </p:blipFill>
+        <p:spPr>
+          <a:xfrm>
+            <a:off x="2852928" y="7278561"/>
+            <a:ext cx="18288" cy="316992"/>
+          </a:xfrm>
+          <a:prstGeom prst="rect">
+            <a:avLst/>
+          </a:prstGeom>
+        </p:spPr>
+      </p:pic>
+      <p:sp>
+        <p:nvSpPr>
+          <p:cNvPr id="52" name="p1p-hub-dt l"/>
+          <p:cNvSpPr/>
+          <p:nvPr/>
+        </p:nvSpPr>
+        <p:spPr>
+          <a:xfrm>
+            <a:off x="2822448" y="7395401"/>
+            <a:ext cx="79248" cy="79248"/>
+          </a:xfrm>
+          <a:prstGeom prst="ellipse">
+            <a:avLst/>
+          </a:prstGeom>
+          <a:solidFill>
+            <a:srgbClr val="00A94F"/>
+          </a:solidFill>
+          <a:ln w="18288">
+            <a:solidFill>
+              <a:srgbClr val="FFFFFF"/>
+            </a:solidFill>
+            <a:prstDash val="solid"/>
+          </a:ln>
+        </p:spPr>
+      </p:sp>
+      <p:pic>
+        <p:nvPicPr>
+          <p:cNvPr id="53" name="svg" descr="svg">    </p:cNvPr>
+          <p:cNvPicPr>
+            <a:picLocks noChangeAspect="1"/>
+          </p:cNvPicPr>
+          <p:nvPr/>
+        </p:nvPicPr>
+        <p:blipFill>
+          <a:blip r:embed="rId27"/>
+          <a:stretch>
+            <a:fillRect/>
+          </a:stretch>
+        </p:blipFill>
+        <p:spPr>
+          <a:xfrm>
+            <a:off x="1633728" y="7712139"/>
+            <a:ext cx="182880" cy="182880"/>
+          </a:xfrm>
+          <a:prstGeom prst="rect">
+            <a:avLst/>
+          </a:prstGeom>
+        </p:spPr>
+      </p:pic>
+      <p:sp>
+        <p:nvSpPr>
+          <p:cNvPr id="54" name="p1p-tech"/>
+          <p:cNvSpPr/>
+          <p:nvPr/>
+        </p:nvSpPr>
+        <p:spPr>
+          <a:xfrm>
+            <a:off x="1633728" y="7969949"/>
+            <a:ext cx="438245" cy="182880"/>
+          </a:xfrm>
+          <a:prstGeom prst="roundRect">
+            <a:avLst>
+              <a:gd name="adj" fmla="val 50000"/>
+            </a:avLst>
+          </a:prstGeom>
+          <a:solidFill>
+            <a:srgbClr val="EEF4FC"/>
+          </a:solidFill>
+          <a:ln/>
+        </p:spPr>
+      </p:sp>
+      <p:sp>
+        <p:nvSpPr>
+          <p:cNvPr id="55" name="p1p-role"/>
+          <p:cNvSpPr/>
+          <p:nvPr/>
+        </p:nvSpPr>
+        <p:spPr>
+          <a:xfrm>
+            <a:off x="4328160" y="7599617"/>
+            <a:ext cx="2712720" cy="836676"/>
+          </a:xfrm>
+          <a:prstGeom prst="roundRect">
+            <a:avLst>
+              <a:gd name="adj" fmla="val 12386"/>
+            </a:avLst>
+          </a:prstGeom>
+          <a:solidFill>
+            <a:srgbClr val="FFFFFF"/>
+          </a:solidFill>
+          <a:ln w="12192">
+            <a:solidFill>
+              <a:srgbClr val="D8E0EB"/>
+            </a:solidFill>
+            <a:prstDash val="solid"/>
+          </a:ln>
+        </p:spPr>
+      </p:sp>
+      <p:pic>
+        <p:nvPicPr>
+          <p:cNvPr id="56" name="p1p-hub-st r" descr="p1p-hub-st r">    </p:cNvPr>
+          <p:cNvPicPr>
+            <a:picLocks noChangeAspect="1"/>
+          </p:cNvPicPr>
+          <p:nvPr/>
+        </p:nvPicPr>
+        <p:blipFill>
+          <a:blip r:embed="rId28"/>
+          <a:stretch>
+            <a:fillRect/>
+          </a:stretch>
+        </p:blipFill>
+        <p:spPr>
+          <a:xfrm>
+            <a:off x="5675376" y="7278561"/>
+            <a:ext cx="18288" cy="316992"/>
+          </a:xfrm>
+          <a:prstGeom prst="rect">
+            <a:avLst/>
+          </a:prstGeom>
+        </p:spPr>
+      </p:pic>
+      <p:sp>
+        <p:nvSpPr>
+          <p:cNvPr id="57" name="p1p-hub-dt r"/>
+          <p:cNvSpPr/>
+          <p:nvPr/>
+        </p:nvSpPr>
+        <p:spPr>
+          <a:xfrm>
+            <a:off x="5644896" y="7395401"/>
+            <a:ext cx="79248" cy="79248"/>
+          </a:xfrm>
+          <a:prstGeom prst="ellipse">
+            <a:avLst/>
+          </a:prstGeom>
+          <a:solidFill>
+            <a:srgbClr val="00A94F"/>
+          </a:solidFill>
+          <a:ln w="18288">
+            <a:solidFill>
+              <a:srgbClr val="FFFFFF"/>
+            </a:solidFill>
+            <a:prstDash val="solid"/>
+          </a:ln>
+        </p:spPr>
+      </p:sp>
+      <p:pic>
+        <p:nvPicPr>
+          <p:cNvPr id="58" name="svg" descr="svg">    </p:cNvPr>
+          <p:cNvPicPr>
+            <a:picLocks noChangeAspect="1"/>
+          </p:cNvPicPr>
+          <p:nvPr/>
+        </p:nvPicPr>
+        <p:blipFill>
+          <a:blip r:embed="rId29"/>
+          <a:stretch>
+            <a:fillRect/>
+          </a:stretch>
+        </p:blipFill>
+        <p:spPr>
+          <a:xfrm>
+            <a:off x="4456176" y="7712139"/>
+            <a:ext cx="182880" cy="182880"/>
+          </a:xfrm>
+          <a:prstGeom prst="rect">
+            <a:avLst/>
+          </a:prstGeom>
+        </p:spPr>
+      </p:pic>
+      <p:sp>
+        <p:nvSpPr>
+          <p:cNvPr id="59" name="i"/>
+          <p:cNvSpPr/>
+          <p:nvPr/>
+        </p:nvSpPr>
+        <p:spPr>
+          <a:xfrm>
+            <a:off x="862584" y="8498300"/>
+            <a:ext cx="79248" cy="79248"/>
+          </a:xfrm>
+          <a:prstGeom prst="ellipse">
+            <a:avLst/>
+          </a:prstGeom>
+          <a:solidFill>
+            <a:srgbClr val="2F85E0"/>
+          </a:solidFill>
+          <a:ln w="18288">
+            <a:solidFill>
+              <a:srgbClr val="FFFFFF"/>
+            </a:solidFill>
+            <a:prstDash val="solid"/>
+          </a:ln>
+        </p:spPr>
+      </p:sp>
+      <p:pic>
+        <p:nvPicPr>
+          <p:cNvPr id="60" name="svg" descr="svg">    </p:cNvPr>
+          <p:cNvPicPr>
+            <a:picLocks noChangeAspect="1"/>
+          </p:cNvPicPr>
+          <p:nvPr/>
+        </p:nvPicPr>
+        <p:blipFill>
+          <a:blip r:embed="rId30"/>
+          <a:stretch>
+            <a:fillRect/>
+          </a:stretch>
+        </p:blipFill>
+        <p:spPr>
+          <a:xfrm>
+            <a:off x="512064" y="8631428"/>
+            <a:ext cx="780288" cy="780288"/>
+          </a:xfrm>
+          <a:prstGeom prst="rect">
+            <a:avLst/>
+          </a:prstGeom>
+        </p:spPr>
+      </p:pic>
+      <p:sp>
+        <p:nvSpPr>
+          <p:cNvPr id="61" name="s"/>
+          <p:cNvSpPr/>
+          <p:nvPr/>
+        </p:nvSpPr>
+        <p:spPr>
+          <a:xfrm>
+            <a:off x="1727930" y="8727662"/>
+            <a:ext cx="134112" cy="12192"/>
+          </a:xfrm>
+          <a:prstGeom prst="rect">
+            <a:avLst/>
+          </a:prstGeom>
+          <a:solidFill>
+            <a:srgbClr val="C3CEDD"/>
+          </a:solidFill>
+          <a:ln/>
+        </p:spPr>
+      </p:sp>
+      <p:sp>
+        <p:nvSpPr>
+          <p:cNvPr id="62" name="p1p-fact gold ic"/>
+          <p:cNvSpPr/>
+          <p:nvPr/>
+        </p:nvSpPr>
+        <p:spPr>
+          <a:xfrm>
+            <a:off x="1505712" y="9118664"/>
+            <a:ext cx="1738503" cy="268224"/>
+          </a:xfrm>
+          <a:prstGeom prst="roundRect">
+            <a:avLst>
+              <a:gd name="adj" fmla="val 50000"/>
+            </a:avLst>
+          </a:prstGeom>
+          <a:solidFill>
+            <a:srgbClr val="FFF4DB"/>
+          </a:solidFill>
+          <a:ln w="12192">
+            <a:solidFill>
+              <a:srgbClr val="FFF4DB"/>
+            </a:solidFill>
+            <a:prstDash val="solid"/>
+          </a:ln>
+        </p:spPr>
+      </p:sp>
+      <p:pic>
+        <p:nvPicPr>
+          <p:cNvPr id="63" name="svg" descr="svg">    </p:cNvPr>
+          <p:cNvPicPr>
+            <a:picLocks noChangeAspect="1"/>
+          </p:cNvPicPr>
+          <p:nvPr/>
+        </p:nvPicPr>
+        <p:blipFill>
+          <a:blip r:embed="rId31"/>
+          <a:stretch>
+            <a:fillRect/>
+          </a:stretch>
+        </p:blipFill>
+        <p:spPr>
+          <a:xfrm>
+            <a:off x="1635760" y="9199944"/>
+            <a:ext cx="105664" cy="105664"/>
+          </a:xfrm>
+          <a:prstGeom prst="rect">
+            <a:avLst/>
+          </a:prstGeom>
+        </p:spPr>
+      </p:pic>
+      <p:pic>
+        <p:nvPicPr>
+          <p:cNvPr id="64" name="p1p-fact gold" descr="p1p-fact gold">    </p:cNvPr>
+          <p:cNvPicPr>
+            <a:picLocks noChangeAspect="1"/>
+          </p:cNvPicPr>
+          <p:nvPr/>
+        </p:nvPicPr>
+        <p:blipFill>
+          <a:blip r:embed="rId32"/>
+          <a:stretch>
+            <a:fillRect/>
+          </a:stretch>
+        </p:blipFill>
+        <p:spPr>
+          <a:xfrm>
+            <a:off x="3309239" y="9112568"/>
+            <a:ext cx="1706880" cy="280416"/>
+          </a:xfrm>
+          <a:prstGeom prst="rect">
+            <a:avLst/>
+          </a:prstGeom>
+        </p:spPr>
+      </p:pic>
+      <p:sp>
+        <p:nvSpPr>
+          <p:cNvPr id="65" name="key"/>
           <p:cNvSpPr/>
           <p:nvPr/>
         </p:nvSpPr>
@@ -1835,7 +2562,7 @@
       </p:sp>
       <p:sp>
         <p:nvSpPr>
-          <p:cNvPr id="36" name="i"/>
+          <p:cNvPr id="66" name="i"/>
           <p:cNvSpPr/>
           <p:nvPr/>
         </p:nvSpPr>
@@ -1855,7 +2582,7 @@
       </p:sp>
       <p:sp>
         <p:nvSpPr>
-          <p:cNvPr id="37" name="b"/>
+          <p:cNvPr id="67" name="b"/>
           <p:cNvSpPr/>
           <p:nvPr/>
         </p:nvSpPr>
@@ -1875,7 +2602,7 @@
       </p:sp>
       <p:sp>
         <p:nvSpPr>
-          <p:cNvPr id="38" name="i"/>
+          <p:cNvPr id="68" name="i"/>
           <p:cNvSpPr/>
           <p:nvPr/>
         </p:nvSpPr>
@@ -1895,7 +2622,7 @@
       </p:sp>
       <p:sp>
         <p:nvSpPr>
-          <p:cNvPr id="39" name="b"/>
+          <p:cNvPr id="69" name="b"/>
           <p:cNvSpPr/>
           <p:nvPr/>
         </p:nvSpPr>
@@ -1915,7 +2642,7 @@
       </p:sp>
       <p:sp>
         <p:nvSpPr>
-          <p:cNvPr id="40" name="i"/>
+          <p:cNvPr id="70" name="i"/>
           <p:cNvSpPr/>
           <p:nvPr/>
         </p:nvSpPr>
@@ -1935,7 +2662,7 @@
       </p:sp>
       <p:sp>
         <p:nvSpPr>
-          <p:cNvPr id="41" name="01"/>
+          <p:cNvPr id="71" name="01"/>
           <p:cNvSpPr txBox="1"/>
           <p:nvPr/>
         </p:nvSpPr>
@@ -1974,7 +2701,7 @@
       </p:sp>
       <p:sp>
         <p:nvSpPr>
-          <p:cNvPr id="42" name="PT 주제 1 · 가장 중요하게 생각하는 가치와 실천 경험"/>
+          <p:cNvPr id="72" name="PT 주제 1 · 가장 중요하게 생각하는 가치와 실천 경험"/>
           <p:cNvSpPr txBox="1"/>
           <p:nvPr/>
         </p:nvSpPr>
@@ -2013,7 +2740,7 @@
       </p:sp>
       <p:sp>
         <p:nvSpPr>
-          <p:cNvPr id="43" name="제가 가장 중요하게 생각하는 가치는"/>
+          <p:cNvPr id="73" name="제가 가장 중요하게 생각하는 가치는"/>
           <p:cNvSpPr txBox="1"/>
           <p:nvPr/>
         </p:nvSpPr>
@@ -2052,7 +2779,7 @@
       </p:sp>
       <p:sp>
         <p:nvSpPr>
-          <p:cNvPr id="44" name="공동의 목표를 공유하며"/>
+          <p:cNvPr id="74" name="공동의 목표를 공유하며"/>
           <p:cNvSpPr txBox="1"/>
           <p:nvPr/>
         </p:nvSpPr>
@@ -2105,7 +2832,7 @@
       </p:sp>
       <p:sp>
         <p:nvSpPr>
-          <p:cNvPr id="45" name="함께 성과를 만드는 협업입니다"/>
+          <p:cNvPr id="75" name="함께 성과를 만드는 협업입니다"/>
           <p:cNvSpPr txBox="1"/>
           <p:nvPr/>
         </p:nvSpPr>
@@ -2172,38 +2899,38 @@
       </p:sp>
       <p:sp>
         <p:nvSpPr>
-          <p:cNvPr id="46" name="마감 3주 전"/>
-          <p:cNvSpPr txBox="1"/>
-          <p:nvPr/>
-        </p:nvSpPr>
-        <p:spPr>
-          <a:xfrm>
-            <a:off x="969169" y="2175605"/>
-            <a:ext cx="548831" cy="134112"/>
-          </a:xfrm>
-          <a:prstGeom prst="rect">
-            <a:avLst/>
-          </a:prstGeom>
-          <a:noFill/>
-          <a:ln/>
-        </p:spPr>
-        <p:txBody>
-          <a:bodyPr wrap="none" lIns="0" tIns="0" rIns="0" bIns="0" rtlCol="0" anchor="ctr"/>
-          <a:lstStyle/>
-          <a:p>
-            <a:pPr algn="l" indent="0" marL="0">
-              <a:buNone/>
-            </a:pPr>
-            <a:r>
-              <a:rPr lang="ko-KR" altLang="en-US" sz="864" spc="-9" kern="0" dirty="0">
-                <a:solidFill>
-                  <a:srgbClr val="4B5568"/>
+          <p:cNvPr id="76" name="PROJECT"/>
+          <p:cNvSpPr txBox="1"/>
+          <p:nvPr/>
+        </p:nvSpPr>
+        <p:spPr>
+          <a:xfrm>
+            <a:off x="731520" y="2267045"/>
+            <a:ext cx="707327" cy="134112"/>
+          </a:xfrm>
+          <a:prstGeom prst="rect">
+            <a:avLst/>
+          </a:prstGeom>
+          <a:noFill/>
+          <a:ln/>
+        </p:spPr>
+        <p:txBody>
+          <a:bodyPr wrap="none" lIns="0" tIns="0" rIns="0" bIns="0" rtlCol="0" anchor="ctr"/>
+          <a:lstStyle/>
+          <a:p>
+            <a:pPr algn="l" indent="0" marL="0">
+              <a:buNone/>
+            </a:pPr>
+            <a:r>
+              <a:rPr lang="ko-KR" altLang="en-US" sz="864" spc="138" kern="0" dirty="0">
+                <a:solidFill>
+                  <a:srgbClr val="2A78DD"/>
                 </a:solidFill>
                 <a:latin typeface="Paperlogy 7 Bold" pitchFamily="34" charset="0"/>
                 <a:ea typeface="Paperlogy 7 Bold" pitchFamily="34" charset="-127"/>
                 <a:cs typeface="Paperlogy 7 Bold" pitchFamily="34" charset="-120"/>
               </a:rPr>
-              <a:t>마감 3주 전</a:t>
+              <a:t>PROJECT</a:t>
             </a:r>
             <a:endParaRPr lang="en-US" sz="864" dirty="0"/>
           </a:p>
@@ -2211,38 +2938,38 @@
       </p:sp>
       <p:sp>
         <p:nvSpPr>
-          <p:cNvPr id="47" name="BACKGROUND"/>
-          <p:cNvSpPr txBox="1"/>
-          <p:nvPr/>
-        </p:nvSpPr>
-        <p:spPr>
-          <a:xfrm>
-            <a:off x="2023872" y="2175605"/>
-            <a:ext cx="1086484" cy="134112"/>
-          </a:xfrm>
-          <a:prstGeom prst="rect">
-            <a:avLst/>
-          </a:prstGeom>
-          <a:noFill/>
-          <a:ln/>
-        </p:spPr>
-        <p:txBody>
-          <a:bodyPr wrap="none" lIns="0" tIns="0" rIns="0" bIns="0" rtlCol="0" anchor="ctr"/>
-          <a:lstStyle/>
-          <a:p>
-            <a:pPr algn="l" indent="0" marL="0">
-              <a:buNone/>
-            </a:pPr>
-            <a:r>
-              <a:rPr lang="ko-KR" altLang="en-US" sz="864" spc="138" kern="0" dirty="0">
-                <a:solidFill>
-                  <a:srgbClr val="8691A5"/>
+          <p:cNvPr id="77" name="학생 BIM 경진대회"/>
+          <p:cNvSpPr txBox="1"/>
+          <p:nvPr/>
+        </p:nvSpPr>
+        <p:spPr>
+          <a:xfrm>
+            <a:off x="1591247" y="2267045"/>
+            <a:ext cx="890713" cy="134112"/>
+          </a:xfrm>
+          <a:prstGeom prst="rect">
+            <a:avLst/>
+          </a:prstGeom>
+          <a:noFill/>
+          <a:ln/>
+        </p:spPr>
+        <p:txBody>
+          <a:bodyPr wrap="none" lIns="0" tIns="0" rIns="0" bIns="0" rtlCol="0" anchor="ctr"/>
+          <a:lstStyle/>
+          <a:p>
+            <a:pPr algn="l" indent="0" marL="0">
+              <a:buNone/>
+            </a:pPr>
+            <a:r>
+              <a:rPr lang="ko-KR" altLang="en-US" sz="864" spc="-9" kern="0" dirty="0">
+                <a:solidFill>
+                  <a:srgbClr val="004B8D"/>
                 </a:solidFill>
                 <a:latin typeface="Paperlogy 7 Bold" pitchFamily="34" charset="0"/>
                 <a:ea typeface="Paperlogy 7 Bold" pitchFamily="34" charset="-127"/>
                 <a:cs typeface="Paperlogy 7 Bold" pitchFamily="34" charset="-120"/>
               </a:rPr>
-              <a:t>BACKGROUND</a:t>
+              <a:t>학생 BIM 경진대회</a:t>
             </a:r>
             <a:endParaRPr lang="en-US" sz="864" dirty="0"/>
           </a:p>
@@ -2250,69 +2977,69 @@
       </p:sp>
       <p:sp>
         <p:nvSpPr>
-          <p:cNvPr id="48" name="학생 BIM 경진대회"/>
-          <p:cNvSpPr txBox="1"/>
-          <p:nvPr/>
-        </p:nvSpPr>
-        <p:spPr>
-          <a:xfrm>
-            <a:off x="3280505" y="2162366"/>
-            <a:ext cx="1054075" cy="152400"/>
-          </a:xfrm>
-          <a:prstGeom prst="rect">
-            <a:avLst/>
-          </a:prstGeom>
-          <a:noFill/>
-          <a:ln/>
-        </p:spPr>
-        <p:txBody>
-          <a:bodyPr wrap="none" lIns="0" tIns="0" rIns="0" bIns="0" rtlCol="0" anchor="ctr"/>
-          <a:lstStyle/>
-          <a:p>
-            <a:pPr algn="l" indent="0" marL="0">
-              <a:buNone/>
-            </a:pPr>
-            <a:r>
-              <a:rPr lang="ko-KR" altLang="en-US" sz="1008" dirty="0">
-                <a:solidFill>
-                  <a:srgbClr val="004B8D"/>
+          <p:cNvPr id="78" name="4인 팀"/>
+          <p:cNvSpPr txBox="1"/>
+          <p:nvPr/>
+        </p:nvSpPr>
+        <p:spPr>
+          <a:xfrm>
+            <a:off x="2675382" y="2267045"/>
+            <a:ext cx="334804" cy="134112"/>
+          </a:xfrm>
+          <a:prstGeom prst="rect">
+            <a:avLst/>
+          </a:prstGeom>
+          <a:noFill/>
+          <a:ln/>
+        </p:spPr>
+        <p:txBody>
+          <a:bodyPr wrap="none" lIns="0" tIns="0" rIns="0" bIns="0" rtlCol="0" anchor="ctr"/>
+          <a:lstStyle/>
+          <a:p>
+            <a:pPr algn="l" indent="0" marL="0">
+              <a:buNone/>
+            </a:pPr>
+            <a:r>
+              <a:rPr lang="ko-KR" altLang="en-US" sz="864" spc="-9" kern="0" dirty="0">
+                <a:solidFill>
+                  <a:srgbClr val="0B6B33"/>
                 </a:solidFill>
                 <a:latin typeface="Paperlogy 7 Bold" pitchFamily="34" charset="0"/>
                 <a:ea typeface="Paperlogy 7 Bold" pitchFamily="34" charset="-127"/>
                 <a:cs typeface="Paperlogy 7 Bold" pitchFamily="34" charset="-120"/>
               </a:rPr>
-              <a:t>학생 BIM 경진대회</a:t>
-            </a:r>
-            <a:endParaRPr lang="en-US" sz="1008" dirty="0"/>
-          </a:p>
-        </p:txBody>
-      </p:sp>
-      <p:sp>
-        <p:nvSpPr>
-          <p:cNvPr id="49" name="4인 팀 팀장"/>
-          <p:cNvSpPr txBox="1"/>
-          <p:nvPr/>
-        </p:nvSpPr>
-        <p:spPr>
-          <a:xfrm>
-            <a:off x="4591907" y="2162366"/>
-            <a:ext cx="641128" cy="152400"/>
-          </a:xfrm>
-          <a:prstGeom prst="rect">
-            <a:avLst/>
-          </a:prstGeom>
-          <a:noFill/>
-          <a:ln/>
-        </p:spPr>
-        <p:txBody>
-          <a:bodyPr wrap="none" lIns="0" tIns="0" rIns="0" bIns="0" rtlCol="0" anchor="ctr"/>
-          <a:lstStyle/>
-          <a:p>
-            <a:pPr algn="l" indent="0" marL="0">
-              <a:buNone/>
-            </a:pPr>
-            <a:r>
-              <a:rPr lang="ko-KR" altLang="en-US" sz="1008" dirty="0">
+              <a:t>4인 팀</a:t>
+            </a:r>
+            <a:endParaRPr lang="en-US" sz="864" dirty="0"/>
+          </a:p>
+        </p:txBody>
+      </p:sp>
+      <p:sp>
+        <p:nvSpPr>
+          <p:cNvPr id="79" name="팀장"/>
+          <p:cNvSpPr txBox="1"/>
+          <p:nvPr/>
+        </p:nvSpPr>
+        <p:spPr>
+          <a:xfrm>
+            <a:off x="3205258" y="2267045"/>
+            <a:ext cx="239744" cy="134112"/>
+          </a:xfrm>
+          <a:prstGeom prst="rect">
+            <a:avLst/>
+          </a:prstGeom>
+          <a:noFill/>
+          <a:ln/>
+        </p:spPr>
+        <p:txBody>
+          <a:bodyPr wrap="none" lIns="0" tIns="0" rIns="0" bIns="0" rtlCol="0" anchor="ctr"/>
+          <a:lstStyle/>
+          <a:p>
+            <a:pPr algn="l" indent="0" marL="0">
+              <a:buNone/>
+            </a:pPr>
+            <a:r>
+              <a:rPr lang="ko-KR" altLang="en-US" sz="864" spc="-9" kern="0" dirty="0">
                 <a:solidFill>
                   <a:srgbClr val="0B6B33"/>
                 </a:solidFill>
@@ -2320,7 +3047,85 @@
                 <a:ea typeface="Paperlogy 7 Bold" pitchFamily="34" charset="-127"/>
                 <a:cs typeface="Paperlogy 7 Bold" pitchFamily="34" charset="-120"/>
               </a:rPr>
-              <a:t>4인 팀 팀장</a:t>
+              <a:t>팀장</a:t>
+            </a:r>
+            <a:endParaRPr lang="en-US" sz="864" dirty="0"/>
+          </a:p>
+        </p:txBody>
+      </p:sp>
+      <p:sp>
+        <p:nvSpPr>
+          <p:cNvPr id="80" name="‘유닛 모듈러 기반 사용자 맞춤형 리모델링 방법’"/>
+          <p:cNvSpPr txBox="1"/>
+          <p:nvPr/>
+        </p:nvSpPr>
+        <p:spPr>
+          <a:xfrm>
+            <a:off x="731520" y="2505075"/>
+            <a:ext cx="4080803" cy="256032"/>
+          </a:xfrm>
+          <a:prstGeom prst="rect">
+            <a:avLst/>
+          </a:prstGeom>
+          <a:noFill/>
+          <a:ln/>
+        </p:spPr>
+        <p:txBody>
+          <a:bodyPr wrap="none" lIns="0" tIns="0" rIns="0" bIns="0" rtlCol="0" anchor="ctr"/>
+          <a:lstStyle/>
+          <a:p>
+            <a:pPr algn="l" indent="0" marL="0">
+              <a:buNone/>
+            </a:pPr>
+            <a:r>
+              <a:rPr lang="ko-KR" altLang="en-US" sz="1728" spc="-69" kern="0" dirty="0">
+                <a:solidFill>
+                  <a:srgbClr val="0B2147"/>
+                </a:solidFill>
+                <a:latin typeface="Paperlogy 8 ExtraBold" pitchFamily="34" charset="0"/>
+                <a:ea typeface="Paperlogy 8 ExtraBold" pitchFamily="34" charset="-127"/>
+                <a:cs typeface="Paperlogy 8 ExtraBold" pitchFamily="34" charset="-120"/>
+              </a:rPr>
+              <a:t>‘유닛 모듈러 기반 사용자 맞춤형 리모델링 방법’</a:t>
+            </a:r>
+            <a:endParaRPr lang="en-US" sz="1728" dirty="0"/>
+          </a:p>
+        </p:txBody>
+      </p:sp>
+      <p:sp>
+        <p:nvSpPr>
+          <p:cNvPr id="81" name="사용자가 원하는 리모델링 규모에 따라 유닛 모듈러를 배치하고,"/>
+          <p:cNvSpPr txBox="1"/>
+          <p:nvPr/>
+        </p:nvSpPr>
+        <p:spPr>
+          <a:xfrm>
+            <a:off x="731520" y="2828163"/>
+            <a:ext cx="3255616" cy="152400"/>
+          </a:xfrm>
+          <a:prstGeom prst="rect">
+            <a:avLst/>
+          </a:prstGeom>
+          <a:noFill/>
+          <a:ln/>
+        </p:spPr>
+        <p:txBody>
+          <a:bodyPr wrap="none" lIns="0" tIns="0" rIns="0" bIns="0" rtlCol="0" anchor="ctr"/>
+          <a:lstStyle/>
+          <a:p>
+            <a:pPr algn="l" indent="0" marL="0">
+              <a:buNone/>
+            </a:pPr>
+            <a:r>
+              <a:rPr lang="ko-KR" altLang="en-US" sz="1008" spc="-20" kern="0" dirty="0">
+                <a:solidFill>
+                  <a:srgbClr val="4B5568"/>
+                </a:solidFill>
+                <a:latin typeface="Paperlogy 5 Medium" pitchFamily="34" charset="0"/>
+                <a:ea typeface="Paperlogy 5 Medium" pitchFamily="34" charset="-127"/>
+                <a:cs typeface="Paperlogy 5 Medium" pitchFamily="34" charset="-120"/>
+              </a:rPr>
+              <a:t>사용자가 원하는 리모델링 규모에 따라 유닛 모듈러를 배치하고,</a:t>
             </a:r>
             <a:endParaRPr lang="en-US" sz="1008" dirty="0"/>
           </a:p>
@@ -2328,38 +3133,233 @@
       </p:sp>
       <p:sp>
         <p:nvSpPr>
-          <p:cNvPr id="50" name="주제 미확정"/>
-          <p:cNvSpPr txBox="1"/>
-          <p:nvPr/>
-        </p:nvSpPr>
-        <p:spPr>
-          <a:xfrm>
-            <a:off x="5513451" y="2162366"/>
-            <a:ext cx="640271" cy="152400"/>
-          </a:xfrm>
-          <a:prstGeom prst="rect">
-            <a:avLst/>
-          </a:prstGeom>
-          <a:noFill/>
-          <a:ln/>
-        </p:spPr>
-        <p:txBody>
-          <a:bodyPr wrap="none" lIns="0" tIns="0" rIns="0" bIns="0" rtlCol="0" anchor="ctr"/>
-          <a:lstStyle/>
-          <a:p>
-            <a:pPr algn="l" indent="0" marL="0">
-              <a:buNone/>
-            </a:pPr>
-            <a:r>
-              <a:rPr lang="ko-KR" altLang="en-US" sz="1008" dirty="0">
+          <p:cNvPr id="82" name="필요한 모듈 수와 자재 물량을 자동으로 산출하는 BIM 기반 리모델링 방"/>
+          <p:cNvSpPr txBox="1"/>
+          <p:nvPr/>
+        </p:nvSpPr>
+        <p:spPr>
+          <a:xfrm>
+            <a:off x="731520" y="3020187"/>
+            <a:ext cx="4065659" cy="152400"/>
+          </a:xfrm>
+          <a:prstGeom prst="rect">
+            <a:avLst/>
+          </a:prstGeom>
+          <a:noFill/>
+          <a:ln/>
+        </p:spPr>
+        <p:txBody>
+          <a:bodyPr wrap="none" lIns="0" tIns="0" rIns="0" bIns="0" rtlCol="0" anchor="ctr"/>
+          <a:lstStyle/>
+          <a:p>
+            <a:pPr algn="l" indent="0" marL="0">
+              <a:buNone/>
+            </a:pPr>
+            <a:r>
+              <a:rPr lang="ko-KR" altLang="en-US" sz="1008" spc="-20" kern="0" dirty="0">
                 <a:solidFill>
                   <a:srgbClr val="4B5568"/>
+                </a:solidFill>
+                <a:latin typeface="Paperlogy 5 Medium" pitchFamily="34" charset="0"/>
+                <a:ea typeface="Paperlogy 5 Medium" pitchFamily="34" charset="-127"/>
+                <a:cs typeface="Paperlogy 5 Medium" pitchFamily="34" charset="-120"/>
+              </a:rPr>
+              <a:t>필요한 모듈 수와 자재 물량을 자동으로 산출하는 BIM 기반 리모델링 방법 제안</a:t>
+            </a:r>
+            <a:endParaRPr lang="en-US" sz="1008" dirty="0"/>
+          </a:p>
+        </p:txBody>
+      </p:sp>
+      <p:sp>
+        <p:nvSpPr>
+          <p:cNvPr id="83" name="결과물"/>
+          <p:cNvSpPr txBox="1"/>
+          <p:nvPr/>
+        </p:nvSpPr>
+        <p:spPr>
+          <a:xfrm>
+            <a:off x="5462016" y="2332482"/>
+            <a:ext cx="382905" cy="152400"/>
+          </a:xfrm>
+          <a:prstGeom prst="rect">
+            <a:avLst/>
+          </a:prstGeom>
+          <a:noFill/>
+          <a:ln/>
+        </p:spPr>
+        <p:txBody>
+          <a:bodyPr wrap="none" lIns="0" tIns="0" rIns="0" bIns="0" rtlCol="0" anchor="ctr"/>
+          <a:lstStyle/>
+          <a:p>
+            <a:pPr algn="l" indent="0" marL="0">
+              <a:buNone/>
+            </a:pPr>
+            <a:r>
+              <a:rPr lang="ko-KR" altLang="en-US" sz="1008" spc="-10" kern="0" dirty="0">
+                <a:solidFill>
+                  <a:srgbClr val="8A5A00"/>
+                </a:solidFill>
+                <a:latin typeface="Paperlogy 8 ExtraBold" pitchFamily="34" charset="0"/>
+                <a:ea typeface="Paperlogy 8 ExtraBold" pitchFamily="34" charset="-127"/>
+                <a:cs typeface="Paperlogy 8 ExtraBold" pitchFamily="34" charset="-120"/>
+              </a:rPr>
+              <a:t>결과물</a:t>
+            </a:r>
+            <a:endParaRPr lang="en-US" sz="1008" dirty="0"/>
+          </a:p>
+        </p:txBody>
+      </p:sp>
+      <p:sp>
+        <p:nvSpPr>
+          <p:cNvPr id="84" name="유닛 모듈러 기반 사용자"/>
+          <p:cNvSpPr txBox="1"/>
+          <p:nvPr/>
+        </p:nvSpPr>
+        <p:spPr>
+          <a:xfrm>
+            <a:off x="5242560" y="2566797"/>
+            <a:ext cx="1239648" cy="152400"/>
+          </a:xfrm>
+          <a:prstGeom prst="rect">
+            <a:avLst/>
+          </a:prstGeom>
+          <a:noFill/>
+          <a:ln/>
+        </p:spPr>
+        <p:txBody>
+          <a:bodyPr wrap="none" lIns="0" tIns="0" rIns="0" bIns="0" rtlCol="0" anchor="ctr"/>
+          <a:lstStyle/>
+          <a:p>
+            <a:pPr algn="l" indent="0" marL="0">
+              <a:buNone/>
+            </a:pPr>
+            <a:r>
+              <a:rPr lang="ko-KR" altLang="en-US" sz="1008" spc="-25" kern="0" dirty="0">
+                <a:solidFill>
+                  <a:srgbClr val="8A5A00"/>
+                </a:solidFill>
+                <a:latin typeface="Paperlogy 6 SemiBold" pitchFamily="34" charset="0"/>
+                <a:ea typeface="Paperlogy 6 SemiBold" pitchFamily="34" charset="-127"/>
+                <a:cs typeface="Paperlogy 6 SemiBold" pitchFamily="34" charset="-120"/>
+              </a:rPr>
+              <a:t>유닛 모듈러 기반 사용자</a:t>
+            </a:r>
+            <a:endParaRPr lang="en-US" sz="1008" dirty="0"/>
+          </a:p>
+        </p:txBody>
+      </p:sp>
+      <p:sp>
+        <p:nvSpPr>
+          <p:cNvPr id="85" name="맞춤형 리모델링 앱 개발"/>
+          <p:cNvSpPr txBox="1"/>
+          <p:nvPr/>
+        </p:nvSpPr>
+        <p:spPr>
+          <a:xfrm>
+            <a:off x="5242560" y="2745962"/>
+            <a:ext cx="1239648" cy="152400"/>
+          </a:xfrm>
+          <a:prstGeom prst="rect">
+            <a:avLst/>
+          </a:prstGeom>
+          <a:noFill/>
+          <a:ln/>
+        </p:spPr>
+        <p:txBody>
+          <a:bodyPr wrap="none" lIns="0" tIns="0" rIns="0" bIns="0" rtlCol="0" anchor="ctr"/>
+          <a:lstStyle/>
+          <a:p>
+            <a:pPr algn="l" indent="0" marL="0">
+              <a:buNone/>
+            </a:pPr>
+            <a:r>
+              <a:rPr lang="ko-KR" altLang="en-US" sz="1008" spc="-25" kern="0" dirty="0">
+                <a:solidFill>
+                  <a:srgbClr val="8A5A00"/>
+                </a:solidFill>
+                <a:latin typeface="Paperlogy 6 SemiBold" pitchFamily="34" charset="0"/>
+                <a:ea typeface="Paperlogy 6 SemiBold" pitchFamily="34" charset="-127"/>
+                <a:cs typeface="Paperlogy 6 SemiBold" pitchFamily="34" charset="-120"/>
+              </a:rPr>
+              <a:t>맞춤형 리모델링 앱 개발</a:t>
+            </a:r>
+            <a:endParaRPr lang="en-US" sz="1008" dirty="0"/>
+          </a:p>
+        </p:txBody>
+      </p:sp>
+      <p:sp>
+        <p:nvSpPr>
+          <p:cNvPr id="86" name="아이디어 시연 영상"/>
+          <p:cNvSpPr txBox="1"/>
+          <p:nvPr/>
+        </p:nvSpPr>
+        <p:spPr>
+          <a:xfrm>
+            <a:off x="5242560" y="2925128"/>
+            <a:ext cx="981178" cy="152400"/>
+          </a:xfrm>
+          <a:prstGeom prst="rect">
+            <a:avLst/>
+          </a:prstGeom>
+          <a:noFill/>
+          <a:ln/>
+        </p:spPr>
+        <p:txBody>
+          <a:bodyPr wrap="none" lIns="0" tIns="0" rIns="0" bIns="0" rtlCol="0" anchor="ctr"/>
+          <a:lstStyle/>
+          <a:p>
+            <a:pPr algn="l" indent="0" marL="0">
+              <a:buNone/>
+            </a:pPr>
+            <a:r>
+              <a:rPr lang="ko-KR" altLang="en-US" sz="1008" spc="-25" kern="0" dirty="0">
+                <a:solidFill>
+                  <a:srgbClr val="8A5A00"/>
+                </a:solidFill>
+                <a:latin typeface="Paperlogy 6 SemiBold" pitchFamily="34" charset="0"/>
+                <a:ea typeface="Paperlogy 6 SemiBold" pitchFamily="34" charset="-127"/>
+                <a:cs typeface="Paperlogy 6 SemiBold" pitchFamily="34" charset="-120"/>
+              </a:rPr>
+              <a:t>아이디어 시연 영상</a:t>
+            </a:r>
+            <a:endParaRPr lang="en-US" sz="1008" dirty="0"/>
+          </a:p>
+        </p:txBody>
+      </p:sp>
+      <p:sp>
+        <p:nvSpPr>
+          <p:cNvPr id="87" name="리모델링"/>
+          <p:cNvSpPr txBox="1"/>
+          <p:nvPr/>
+        </p:nvSpPr>
+        <p:spPr>
+          <a:xfrm>
+            <a:off x="1121664" y="3407283"/>
+            <a:ext cx="484061" cy="152400"/>
+          </a:xfrm>
+          <a:prstGeom prst="rect">
+            <a:avLst/>
+          </a:prstGeom>
+          <a:noFill/>
+          <a:ln/>
+        </p:spPr>
+        <p:txBody>
+          <a:bodyPr wrap="none" lIns="0" tIns="0" rIns="0" bIns="0" rtlCol="0" anchor="ctr"/>
+          <a:lstStyle/>
+          <a:p>
+            <a:pPr algn="l" indent="0" marL="0">
+              <a:buNone/>
+            </a:pPr>
+            <a:r>
+              <a:rPr lang="ko-KR" altLang="en-US" sz="1008" spc="-30" kern="0" dirty="0">
+                <a:solidFill>
+                  <a:srgbClr val="0B2147"/>
                 </a:solidFill>
                 <a:latin typeface="Paperlogy 7 Bold" pitchFamily="34" charset="0"/>
                 <a:ea typeface="Paperlogy 7 Bold" pitchFamily="34" charset="-127"/>
                 <a:cs typeface="Paperlogy 7 Bold" pitchFamily="34" charset="-120"/>
               </a:rPr>
-              <a:t>주제 미확정</a:t>
+              <a:t>리모델링</a:t>
             </a:r>
             <a:endParaRPr lang="en-US" sz="1008" dirty="0"/>
           </a:p>
@@ -2367,91 +3367,208 @@
       </p:sp>
       <p:sp>
         <p:nvSpPr>
-          <p:cNvPr id="51" name="참신성"/>
-          <p:cNvSpPr txBox="1"/>
-          <p:nvPr/>
-        </p:nvSpPr>
-        <p:spPr>
-          <a:xfrm>
-            <a:off x="699659" y="3349085"/>
-            <a:ext cx="331946" cy="134112"/>
-          </a:xfrm>
-          <a:prstGeom prst="rect">
-            <a:avLst/>
-          </a:prstGeom>
-          <a:noFill/>
-          <a:ln/>
-        </p:spPr>
-        <p:txBody>
-          <a:bodyPr wrap="none" lIns="0" tIns="0" rIns="0" bIns="0" rtlCol="0" anchor="ctr"/>
-          <a:lstStyle/>
-          <a:p>
-            <a:pPr algn="ctr" indent="0" marL="0">
-              <a:buNone/>
-            </a:pPr>
-            <a:r>
-              <a:rPr lang="ko-KR" altLang="en-US" sz="864" spc="-17" kern="0" dirty="0">
-                <a:solidFill>
-                  <a:srgbClr val="4B5568"/>
+          <p:cNvPr id="88" name="규모 입력"/>
+          <p:cNvSpPr txBox="1"/>
+          <p:nvPr/>
+        </p:nvSpPr>
+        <p:spPr>
+          <a:xfrm>
+            <a:off x="1121664" y="3573685"/>
+            <a:ext cx="508349" cy="152400"/>
+          </a:xfrm>
+          <a:prstGeom prst="rect">
+            <a:avLst/>
+          </a:prstGeom>
+          <a:noFill/>
+          <a:ln/>
+        </p:spPr>
+        <p:txBody>
+          <a:bodyPr wrap="none" lIns="0" tIns="0" rIns="0" bIns="0" rtlCol="0" anchor="ctr"/>
+          <a:lstStyle/>
+          <a:p>
+            <a:pPr algn="l" indent="0" marL="0">
+              <a:buNone/>
+            </a:pPr>
+            <a:r>
+              <a:rPr lang="ko-KR" altLang="en-US" sz="1008" spc="-30" kern="0" dirty="0">
+                <a:solidFill>
+                  <a:srgbClr val="0B2147"/>
                 </a:solidFill>
                 <a:latin typeface="Paperlogy 7 Bold" pitchFamily="34" charset="0"/>
                 <a:ea typeface="Paperlogy 7 Bold" pitchFamily="34" charset="-127"/>
                 <a:cs typeface="Paperlogy 7 Bold" pitchFamily="34" charset="-120"/>
               </a:rPr>
-              <a:t>참신성</a:t>
-            </a:r>
-            <a:endParaRPr lang="en-US" sz="864" dirty="0"/>
-          </a:p>
-        </p:txBody>
-      </p:sp>
-      <p:sp>
-        <p:nvSpPr>
-          <p:cNvPr id="52" name="구현 가능성"/>
-          <p:cNvSpPr txBox="1"/>
-          <p:nvPr/>
-        </p:nvSpPr>
-        <p:spPr>
-          <a:xfrm>
-            <a:off x="1155192" y="3349085"/>
-            <a:ext cx="542544" cy="134112"/>
-          </a:xfrm>
-          <a:prstGeom prst="rect">
-            <a:avLst/>
-          </a:prstGeom>
-          <a:noFill/>
-          <a:ln/>
-        </p:spPr>
-        <p:txBody>
-          <a:bodyPr wrap="none" lIns="0" tIns="0" rIns="0" bIns="0" rtlCol="0" anchor="ctr"/>
-          <a:lstStyle/>
-          <a:p>
-            <a:pPr algn="ctr" indent="0" marL="0">
-              <a:buNone/>
-            </a:pPr>
-            <a:r>
-              <a:rPr lang="ko-KR" altLang="en-US" sz="864" spc="-17" kern="0" dirty="0">
-                <a:solidFill>
-                  <a:srgbClr val="4B5568"/>
+              <a:t>규모 입력</a:t>
+            </a:r>
+            <a:endParaRPr lang="en-US" sz="1008" dirty="0"/>
+          </a:p>
+        </p:txBody>
+      </p:sp>
+      <p:sp>
+        <p:nvSpPr>
+          <p:cNvPr id="89" name="유닛 모듈러"/>
+          <p:cNvSpPr txBox="1"/>
+          <p:nvPr/>
+        </p:nvSpPr>
+        <p:spPr>
+          <a:xfrm>
+            <a:off x="3471958" y="3407283"/>
+            <a:ext cx="617220" cy="152400"/>
+          </a:xfrm>
+          <a:prstGeom prst="rect">
+            <a:avLst/>
+          </a:prstGeom>
+          <a:noFill/>
+          <a:ln/>
+        </p:spPr>
+        <p:txBody>
+          <a:bodyPr wrap="none" lIns="0" tIns="0" rIns="0" bIns="0" rtlCol="0" anchor="ctr"/>
+          <a:lstStyle/>
+          <a:p>
+            <a:pPr algn="l" indent="0" marL="0">
+              <a:buNone/>
+            </a:pPr>
+            <a:r>
+              <a:rPr lang="ko-KR" altLang="en-US" sz="1008" spc="-30" kern="0" dirty="0">
+                <a:solidFill>
+                  <a:srgbClr val="0B2147"/>
                 </a:solidFill>
                 <a:latin typeface="Paperlogy 7 Bold" pitchFamily="34" charset="0"/>
                 <a:ea typeface="Paperlogy 7 Bold" pitchFamily="34" charset="-127"/>
                 <a:cs typeface="Paperlogy 7 Bold" pitchFamily="34" charset="-120"/>
               </a:rPr>
-              <a:t>구현 가능성</a:t>
-            </a:r>
-            <a:endParaRPr lang="en-US" sz="864" dirty="0"/>
-          </a:p>
-        </p:txBody>
-      </p:sp>
-      <p:sp>
-        <p:nvSpPr>
-          <p:cNvPr id="53" name="01"/>
-          <p:cNvSpPr txBox="1"/>
-          <p:nvPr/>
-        </p:nvSpPr>
-        <p:spPr>
-          <a:xfrm>
-            <a:off x="2023872" y="2756249"/>
+              <a:t>유닛 모듈러</a:t>
+            </a:r>
+            <a:endParaRPr lang="en-US" sz="1008" dirty="0"/>
+          </a:p>
+        </p:txBody>
+      </p:sp>
+      <p:sp>
+        <p:nvSpPr>
+          <p:cNvPr id="90" name="배치"/>
+          <p:cNvSpPr txBox="1"/>
+          <p:nvPr/>
+        </p:nvSpPr>
+        <p:spPr>
+          <a:xfrm>
+            <a:off x="3471958" y="3573685"/>
+            <a:ext cx="266414" cy="152400"/>
+          </a:xfrm>
+          <a:prstGeom prst="rect">
+            <a:avLst/>
+          </a:prstGeom>
+          <a:noFill/>
+          <a:ln/>
+        </p:spPr>
+        <p:txBody>
+          <a:bodyPr wrap="none" lIns="0" tIns="0" rIns="0" bIns="0" rtlCol="0" anchor="ctr"/>
+          <a:lstStyle/>
+          <a:p>
+            <a:pPr algn="l" indent="0" marL="0">
+              <a:buNone/>
+            </a:pPr>
+            <a:r>
+              <a:rPr lang="ko-KR" altLang="en-US" sz="1008" spc="-30" kern="0" dirty="0">
+                <a:solidFill>
+                  <a:srgbClr val="0B2147"/>
+                </a:solidFill>
+                <a:latin typeface="Paperlogy 7 Bold" pitchFamily="34" charset="0"/>
+                <a:ea typeface="Paperlogy 7 Bold" pitchFamily="34" charset="-127"/>
+                <a:cs typeface="Paperlogy 7 Bold" pitchFamily="34" charset="-120"/>
+              </a:rPr>
+              <a:t>배치</a:t>
+            </a:r>
+            <a:endParaRPr lang="en-US" sz="1008" dirty="0"/>
+          </a:p>
+        </p:txBody>
+      </p:sp>
+      <p:sp>
+        <p:nvSpPr>
+          <p:cNvPr id="91" name="모듈 수 · 자재 물량"/>
+          <p:cNvSpPr txBox="1"/>
+          <p:nvPr/>
+        </p:nvSpPr>
+        <p:spPr>
+          <a:xfrm>
+            <a:off x="5931122" y="3407283"/>
+            <a:ext cx="950182" cy="152400"/>
+          </a:xfrm>
+          <a:prstGeom prst="rect">
+            <a:avLst/>
+          </a:prstGeom>
+          <a:noFill/>
+          <a:ln/>
+        </p:spPr>
+        <p:txBody>
+          <a:bodyPr wrap="none" lIns="0" tIns="0" rIns="0" bIns="0" rtlCol="0" anchor="ctr"/>
+          <a:lstStyle/>
+          <a:p>
+            <a:pPr algn="l" indent="0" marL="0">
+              <a:buNone/>
+            </a:pPr>
+            <a:r>
+              <a:rPr lang="ko-KR" altLang="en-US" sz="1008" spc="-30" kern="0" dirty="0">
+                <a:solidFill>
+                  <a:srgbClr val="0B2147"/>
+                </a:solidFill>
+                <a:latin typeface="Paperlogy 7 Bold" pitchFamily="34" charset="0"/>
+                <a:ea typeface="Paperlogy 7 Bold" pitchFamily="34" charset="-127"/>
+                <a:cs typeface="Paperlogy 7 Bold" pitchFamily="34" charset="-120"/>
+              </a:rPr>
+              <a:t>모듈 수 · 자재 물량</a:t>
+            </a:r>
+            <a:endParaRPr lang="en-US" sz="1008" dirty="0"/>
+          </a:p>
+        </p:txBody>
+      </p:sp>
+      <p:sp>
+        <p:nvSpPr>
+          <p:cNvPr id="92" name="자동 산출"/>
+          <p:cNvSpPr txBox="1"/>
+          <p:nvPr/>
+        </p:nvSpPr>
+        <p:spPr>
+          <a:xfrm>
+            <a:off x="5931122" y="3573685"/>
+            <a:ext cx="508349" cy="152400"/>
+          </a:xfrm>
+          <a:prstGeom prst="rect">
+            <a:avLst/>
+          </a:prstGeom>
+          <a:noFill/>
+          <a:ln/>
+        </p:spPr>
+        <p:txBody>
+          <a:bodyPr wrap="none" lIns="0" tIns="0" rIns="0" bIns="0" rtlCol="0" anchor="ctr"/>
+          <a:lstStyle/>
+          <a:p>
+            <a:pPr algn="l" indent="0" marL="0">
+              <a:buNone/>
+            </a:pPr>
+            <a:r>
+              <a:rPr lang="ko-KR" altLang="en-US" sz="1008" spc="-30" kern="0" dirty="0">
+                <a:solidFill>
+                  <a:srgbClr val="0B2147"/>
+                </a:solidFill>
+                <a:latin typeface="Paperlogy 7 Bold" pitchFamily="34" charset="0"/>
+                <a:ea typeface="Paperlogy 7 Bold" pitchFamily="34" charset="-127"/>
+                <a:cs typeface="Paperlogy 7 Bold" pitchFamily="34" charset="-120"/>
+              </a:rPr>
+              <a:t>자동 산출</a:t>
+            </a:r>
+            <a:endParaRPr lang="en-US" sz="1008" dirty="0"/>
+          </a:p>
+        </p:txBody>
+      </p:sp>
+      <p:sp>
+        <p:nvSpPr>
+          <p:cNvPr id="93" name="01"/>
+          <p:cNvSpPr txBox="1"/>
+          <p:nvPr/>
+        </p:nvSpPr>
+        <p:spPr>
+          <a:xfrm>
+            <a:off x="1499616" y="4047363"/>
             <a:ext cx="203930" cy="134112"/>
           </a:xfrm>
           <a:prstGeom prst="rect">
@@ -2484,13 +3601,13 @@
       </p:sp>
       <p:sp>
         <p:nvSpPr>
-          <p:cNvPr id="54" name="CONFLICT"/>
-          <p:cNvSpPr txBox="1"/>
-          <p:nvPr/>
-        </p:nvSpPr>
-        <p:spPr>
-          <a:xfrm>
-            <a:off x="2459450" y="2756249"/>
+          <p:cNvPr id="94" name="CONFLICT"/>
+          <p:cNvSpPr txBox="1"/>
+          <p:nvPr/>
+        </p:nvSpPr>
+        <p:spPr>
+          <a:xfrm>
+            <a:off x="1935194" y="4047363"/>
             <a:ext cx="771906" cy="134112"/>
           </a:xfrm>
           <a:prstGeom prst="rect">
@@ -2523,14 +3640,14 @@
       </p:sp>
       <p:sp>
         <p:nvSpPr>
-          <p:cNvPr id="55" name="서로 다른 의견"/>
-          <p:cNvSpPr txBox="1"/>
-          <p:nvPr/>
-        </p:nvSpPr>
-        <p:spPr>
-          <a:xfrm>
-            <a:off x="2023872" y="2964085"/>
-            <a:ext cx="956139" cy="188976"/>
+          <p:cNvPr id="95" name="주제 선정 의견 충돌"/>
+          <p:cNvSpPr txBox="1"/>
+          <p:nvPr/>
+        </p:nvSpPr>
+        <p:spPr>
+          <a:xfrm>
+            <a:off x="1499616" y="4230815"/>
+            <a:ext cx="1285890" cy="188976"/>
           </a:xfrm>
           <a:prstGeom prst="rect">
             <a:avLst/>
@@ -2554,7 +3671,7 @@
                 <a:ea typeface="Paperlogy 7 Bold" pitchFamily="34" charset="-127"/>
                 <a:cs typeface="Paperlogy 7 Bold" pitchFamily="34" charset="-120"/>
               </a:rPr>
-              <a:t>서로 다른 의견</a:t>
+              <a:t>주제 선정 의견 충돌</a:t>
             </a:r>
             <a:endParaRPr lang="en-US" sz="1296" dirty="0"/>
           </a:p>
@@ -2562,30 +3679,30 @@
       </p:sp>
       <p:sp>
         <p:nvSpPr>
-          <p:cNvPr id="56" name="참신성 ↔ 구현 가능성"/>
-          <p:cNvSpPr txBox="1"/>
-          <p:nvPr/>
-        </p:nvSpPr>
-        <p:spPr>
-          <a:xfrm>
-            <a:off x="2304288" y="3395948"/>
-            <a:ext cx="1341724" cy="176784"/>
-          </a:xfrm>
-          <a:prstGeom prst="rect">
-            <a:avLst/>
-          </a:prstGeom>
-          <a:noFill/>
-          <a:ln/>
-        </p:spPr>
-        <p:txBody>
-          <a:bodyPr wrap="none" lIns="0" tIns="0" rIns="0" bIns="0" rtlCol="0" anchor="ctr"/>
-          <a:lstStyle/>
-          <a:p>
-            <a:pPr algn="l" indent="0" marL="0">
-              <a:buNone/>
-            </a:pPr>
-            <a:r>
-              <a:rPr lang="ko-KR" altLang="en-US" sz="1200" spc="-24" kern="0" dirty="0">
+          <p:cNvPr id="96" name="참신성 ↔ 구현 가능성"/>
+          <p:cNvSpPr txBox="1"/>
+          <p:nvPr/>
+        </p:nvSpPr>
+        <p:spPr>
+          <a:xfrm>
+            <a:off x="1749552" y="4553141"/>
+            <a:ext cx="1127072" cy="152400"/>
+          </a:xfrm>
+          <a:prstGeom prst="rect">
+            <a:avLst/>
+          </a:prstGeom>
+          <a:noFill/>
+          <a:ln/>
+        </p:spPr>
+        <p:txBody>
+          <a:bodyPr wrap="none" lIns="0" tIns="0" rIns="0" bIns="0" rtlCol="0" anchor="ctr"/>
+          <a:lstStyle/>
+          <a:p>
+            <a:pPr algn="l" indent="0" marL="0">
+              <a:buNone/>
+            </a:pPr>
+            <a:r>
+              <a:rPr lang="ko-KR" altLang="en-US" sz="1008" spc="-20" kern="0" dirty="0">
                 <a:solidFill>
                   <a:srgbClr val="4B5568"/>
                 </a:solidFill>
@@ -2595,36 +3712,36 @@
               </a:rPr>
               <a:t>참신성 ↔ 구현 가능성</a:t>
             </a:r>
-            <a:endParaRPr lang="en-US" sz="1200" dirty="0"/>
-          </a:p>
-        </p:txBody>
-      </p:sp>
-      <p:sp>
-        <p:nvSpPr>
-          <p:cNvPr id="57" name="마감 3주 전 주제 미확정"/>
-          <p:cNvSpPr txBox="1"/>
-          <p:nvPr/>
-        </p:nvSpPr>
-        <p:spPr>
-          <a:xfrm>
-            <a:off x="4852416" y="3395948"/>
-            <a:ext cx="1484085" cy="176784"/>
-          </a:xfrm>
-          <a:prstGeom prst="rect">
-            <a:avLst/>
-          </a:prstGeom>
-          <a:noFill/>
-          <a:ln/>
-        </p:spPr>
-        <p:txBody>
-          <a:bodyPr wrap="none" lIns="0" tIns="0" rIns="0" bIns="0" rtlCol="0" anchor="ctr"/>
-          <a:lstStyle/>
-          <a:p>
-            <a:pPr algn="l" indent="0" marL="0">
-              <a:buNone/>
-            </a:pPr>
-            <a:r>
-              <a:rPr lang="ko-KR" altLang="en-US" sz="1200" spc="-24" kern="0" dirty="0">
+            <a:endParaRPr lang="en-US" sz="1008" dirty="0"/>
+          </a:p>
+        </p:txBody>
+      </p:sp>
+      <p:sp>
+        <p:nvSpPr>
+          <p:cNvPr id="97" name="마감 3주 전까지 주제 미확정"/>
+          <p:cNvSpPr txBox="1"/>
+          <p:nvPr/>
+        </p:nvSpPr>
+        <p:spPr>
+          <a:xfrm>
+            <a:off x="3312700" y="4553141"/>
+            <a:ext cx="1480046" cy="152400"/>
+          </a:xfrm>
+          <a:prstGeom prst="rect">
+            <a:avLst/>
+          </a:prstGeom>
+          <a:noFill/>
+          <a:ln/>
+        </p:spPr>
+        <p:txBody>
+          <a:bodyPr wrap="none" lIns="0" tIns="0" rIns="0" bIns="0" rtlCol="0" anchor="ctr"/>
+          <a:lstStyle/>
+          <a:p>
+            <a:pPr algn="l" indent="0" marL="0">
+              <a:buNone/>
+            </a:pPr>
+            <a:r>
+              <a:rPr lang="ko-KR" altLang="en-US" sz="1008" spc="-20" kern="0" dirty="0">
                 <a:solidFill>
                   <a:srgbClr val="4B5568"/>
                 </a:solidFill>
@@ -2632,22 +3749,22 @@
                 <a:ea typeface="Paperlogy 6 SemiBold" pitchFamily="34" charset="-127"/>
                 <a:cs typeface="Paperlogy 6 SemiBold" pitchFamily="34" charset="-120"/>
               </a:rPr>
-              <a:t>마감 3주 전 주제 미확정</a:t>
-            </a:r>
-            <a:endParaRPr lang="en-US" sz="1200" dirty="0"/>
-          </a:p>
-        </p:txBody>
-      </p:sp>
-      <p:sp>
-        <p:nvSpPr>
-          <p:cNvPr id="58" name="공통"/>
-          <p:cNvSpPr txBox="1"/>
-          <p:nvPr/>
-        </p:nvSpPr>
-        <p:spPr>
-          <a:xfrm>
-            <a:off x="1027271" y="4758785"/>
-            <a:ext cx="237554" cy="134112"/>
+              <a:t>마감 3주 전까지 주제 미확정</a:t>
+            </a:r>
+            <a:endParaRPr lang="en-US" sz="1008" dirty="0"/>
+          </a:p>
+        </p:txBody>
+      </p:sp>
+      <p:sp>
+        <p:nvSpPr>
+          <p:cNvPr id="98" name="기준"/>
+          <p:cNvSpPr txBox="1"/>
+          <p:nvPr/>
+        </p:nvSpPr>
+        <p:spPr>
+          <a:xfrm>
+            <a:off x="784527" y="5303377"/>
+            <a:ext cx="235363" cy="134112"/>
           </a:xfrm>
           <a:prstGeom prst="rect">
             <a:avLst/>
@@ -2663,7 +3780,7 @@
               <a:buNone/>
             </a:pPr>
             <a:r>
-              <a:rPr lang="ko-KR" altLang="en-US" sz="864" spc="-17" kern="0" dirty="0">
+              <a:rPr lang="ko-KR" altLang="en-US" sz="864" spc="-26" kern="0" dirty="0">
                 <a:solidFill>
                   <a:srgbClr val="FFFFFF"/>
                 </a:solidFill>
@@ -2671,7 +3788,7 @@
                 <a:ea typeface="Paperlogy 7 Bold" pitchFamily="34" charset="-127"/>
                 <a:cs typeface="Paperlogy 7 Bold" pitchFamily="34" charset="-120"/>
               </a:rPr>
-              <a:t>공통</a:t>
+              <a:t>기준</a:t>
             </a:r>
             <a:endParaRPr lang="en-US" sz="864" dirty="0"/>
           </a:p>
@@ -2679,38 +3796,77 @@
       </p:sp>
       <p:sp>
         <p:nvSpPr>
-          <p:cNvPr id="59" name="기준"/>
-          <p:cNvSpPr txBox="1"/>
-          <p:nvPr/>
-        </p:nvSpPr>
-        <p:spPr>
-          <a:xfrm>
-            <a:off x="1027271" y="4884896"/>
-            <a:ext cx="237554" cy="134112"/>
-          </a:xfrm>
-          <a:prstGeom prst="rect">
-            <a:avLst/>
-          </a:prstGeom>
-          <a:noFill/>
-          <a:ln/>
-        </p:spPr>
-        <p:txBody>
-          <a:bodyPr wrap="none" lIns="0" tIns="0" rIns="0" bIns="0" rtlCol="0" anchor="ctr"/>
-          <a:lstStyle/>
-          <a:p>
-            <a:pPr algn="ctr" indent="0" marL="0">
-              <a:buNone/>
-            </a:pPr>
-            <a:r>
-              <a:rPr lang="ko-KR" altLang="en-US" sz="864" spc="-17" kern="0" dirty="0">
-                <a:solidFill>
-                  <a:srgbClr val="FFFFFF"/>
+          <p:cNvPr id="99" name="02"/>
+          <p:cNvSpPr txBox="1"/>
+          <p:nvPr/>
+        </p:nvSpPr>
+        <p:spPr>
+          <a:xfrm>
+            <a:off x="1499616" y="5018723"/>
+            <a:ext cx="203930" cy="134112"/>
+          </a:xfrm>
+          <a:prstGeom prst="rect">
+            <a:avLst/>
+          </a:prstGeom>
+          <a:noFill/>
+          <a:ln/>
+        </p:spPr>
+        <p:txBody>
+          <a:bodyPr wrap="none" lIns="0" tIns="0" rIns="0" bIns="0" rtlCol="0" anchor="ctr"/>
+          <a:lstStyle/>
+          <a:p>
+            <a:pPr algn="l" indent="0" marL="0">
+              <a:buNone/>
+            </a:pPr>
+            <a:r>
+              <a:rPr lang="ko-KR" altLang="en-US" sz="864" spc="35" kern="0" dirty="0">
+                <a:solidFill>
+                  <a:srgbClr val="004B8D"/>
+                </a:solidFill>
+                <a:latin typeface="Paperlogy 8 ExtraBold" pitchFamily="34" charset="0"/>
+                <a:ea typeface="Paperlogy 8 ExtraBold" pitchFamily="34" charset="-127"/>
+                <a:cs typeface="Paperlogy 8 ExtraBold" pitchFamily="34" charset="-120"/>
+              </a:rPr>
+              <a:t>02</a:t>
+            </a:r>
+            <a:endParaRPr lang="en-US" sz="864" dirty="0"/>
+          </a:p>
+        </p:txBody>
+      </p:sp>
+      <p:sp>
+        <p:nvSpPr>
+          <p:cNvPr id="100" name="ALIGN"/>
+          <p:cNvSpPr txBox="1"/>
+          <p:nvPr/>
+        </p:nvSpPr>
+        <p:spPr>
+          <a:xfrm>
+            <a:off x="1935194" y="5018723"/>
+            <a:ext cx="495776" cy="134112"/>
+          </a:xfrm>
+          <a:prstGeom prst="rect">
+            <a:avLst/>
+          </a:prstGeom>
+          <a:noFill/>
+          <a:ln/>
+        </p:spPr>
+        <p:txBody>
+          <a:bodyPr wrap="none" lIns="0" tIns="0" rIns="0" bIns="0" rtlCol="0" anchor="ctr"/>
+          <a:lstStyle/>
+          <a:p>
+            <a:pPr algn="l" indent="0" marL="0">
+              <a:buNone/>
+            </a:pPr>
+            <a:r>
+              <a:rPr lang="ko-KR" altLang="en-US" sz="864" spc="138" kern="0" dirty="0">
+                <a:solidFill>
+                  <a:srgbClr val="2A78DD"/>
                 </a:solidFill>
                 <a:latin typeface="Paperlogy 7 Bold" pitchFamily="34" charset="0"/>
                 <a:ea typeface="Paperlogy 7 Bold" pitchFamily="34" charset="-127"/>
                 <a:cs typeface="Paperlogy 7 Bold" pitchFamily="34" charset="-120"/>
               </a:rPr>
-              <a:t>기준</a:t>
+              <a:t>ALIGN</a:t>
             </a:r>
             <a:endParaRPr lang="en-US" sz="864" dirty="0"/>
           </a:p>
@@ -2718,13 +3874,169 @@
       </p:sp>
       <p:sp>
         <p:nvSpPr>
-          <p:cNvPr id="60" name="02"/>
-          <p:cNvSpPr txBox="1"/>
-          <p:nvPr/>
-        </p:nvSpPr>
-        <p:spPr>
-          <a:xfrm>
-            <a:off x="2023872" y="4424077"/>
+          <p:cNvPr id="101" name="의견 조율 · 주제 확정"/>
+          <p:cNvSpPr txBox="1"/>
+          <p:nvPr/>
+        </p:nvSpPr>
+        <p:spPr>
+          <a:xfrm>
+            <a:off x="1499616" y="5202174"/>
+            <a:ext cx="1369994" cy="188976"/>
+          </a:xfrm>
+          <a:prstGeom prst="rect">
+            <a:avLst/>
+          </a:prstGeom>
+          <a:noFill/>
+          <a:ln/>
+        </p:spPr>
+        <p:txBody>
+          <a:bodyPr wrap="none" lIns="0" tIns="0" rIns="0" bIns="0" rtlCol="0" anchor="ctr"/>
+          <a:lstStyle/>
+          <a:p>
+            <a:pPr algn="l" indent="0" marL="0">
+              <a:buNone/>
+            </a:pPr>
+            <a:r>
+              <a:rPr lang="ko-KR" altLang="en-US" sz="1296" spc="-39" kern="0" dirty="0">
+                <a:solidFill>
+                  <a:srgbClr val="0B2147"/>
+                </a:solidFill>
+                <a:latin typeface="Paperlogy 7 Bold" pitchFamily="34" charset="0"/>
+                <a:ea typeface="Paperlogy 7 Bold" pitchFamily="34" charset="-127"/>
+                <a:cs typeface="Paperlogy 7 Bold" pitchFamily="34" charset="-120"/>
+              </a:rPr>
+              <a:t>의견 조율 · 주제 확정</a:t>
+            </a:r>
+            <a:endParaRPr lang="en-US" sz="1296" dirty="0"/>
+          </a:p>
+        </p:txBody>
+      </p:sp>
+      <p:sp>
+        <p:nvSpPr>
+          <p:cNvPr id="102" name="경청 · 수상작 분석 · 교수님 조언"/>
+          <p:cNvSpPr txBox="1"/>
+          <p:nvPr/>
+        </p:nvSpPr>
+        <p:spPr>
+          <a:xfrm>
+            <a:off x="1749552" y="5524500"/>
+            <a:ext cx="1641691" cy="152400"/>
+          </a:xfrm>
+          <a:prstGeom prst="rect">
+            <a:avLst/>
+          </a:prstGeom>
+          <a:noFill/>
+          <a:ln/>
+        </p:spPr>
+        <p:txBody>
+          <a:bodyPr wrap="none" lIns="0" tIns="0" rIns="0" bIns="0" rtlCol="0" anchor="ctr"/>
+          <a:lstStyle/>
+          <a:p>
+            <a:pPr algn="l" indent="0" marL="0">
+              <a:buNone/>
+            </a:pPr>
+            <a:r>
+              <a:rPr lang="ko-KR" altLang="en-US" sz="1008" spc="-20" kern="0" dirty="0">
+                <a:solidFill>
+                  <a:srgbClr val="4B5568"/>
+                </a:solidFill>
+                <a:latin typeface="Paperlogy 6 SemiBold" pitchFamily="34" charset="0"/>
+                <a:ea typeface="Paperlogy 6 SemiBold" pitchFamily="34" charset="-127"/>
+                <a:cs typeface="Paperlogy 6 SemiBold" pitchFamily="34" charset="-120"/>
+              </a:rPr>
+              <a:t>경청 · 수상작 분석 · 교수님 조언</a:t>
+            </a:r>
+            <a:endParaRPr lang="en-US" sz="1008" dirty="0"/>
+          </a:p>
+        </p:txBody>
+      </p:sp>
+      <p:sp>
+        <p:nvSpPr>
+          <p:cNvPr id="103" name="판단 기준 마련"/>
+          <p:cNvSpPr txBox="1"/>
+          <p:nvPr/>
+        </p:nvSpPr>
+        <p:spPr>
+          <a:xfrm>
+            <a:off x="3889629" y="5524500"/>
+            <a:ext cx="760571" cy="152400"/>
+          </a:xfrm>
+          <a:prstGeom prst="rect">
+            <a:avLst/>
+          </a:prstGeom>
+          <a:noFill/>
+          <a:ln/>
+        </p:spPr>
+        <p:txBody>
+          <a:bodyPr wrap="none" lIns="0" tIns="0" rIns="0" bIns="0" rtlCol="0" anchor="ctr"/>
+          <a:lstStyle/>
+          <a:p>
+            <a:pPr algn="l" indent="0" marL="0">
+              <a:buNone/>
+            </a:pPr>
+            <a:r>
+              <a:rPr lang="ko-KR" altLang="en-US" sz="1008" spc="-20" kern="0" dirty="0">
+                <a:solidFill>
+                  <a:srgbClr val="4B5568"/>
+                </a:solidFill>
+                <a:latin typeface="Paperlogy 6 SemiBold" pitchFamily="34" charset="0"/>
+                <a:ea typeface="Paperlogy 6 SemiBold" pitchFamily="34" charset="-127"/>
+                <a:cs typeface="Paperlogy 6 SemiBold" pitchFamily="34" charset="-120"/>
+              </a:rPr>
+              <a:t>판단 기준 마련</a:t>
+            </a:r>
+            <a:endParaRPr lang="en-US" sz="1008" dirty="0"/>
+          </a:p>
+        </p:txBody>
+      </p:sp>
+      <p:sp>
+        <p:nvSpPr>
+          <p:cNvPr id="104" name="주제 합의"/>
+          <p:cNvSpPr txBox="1"/>
+          <p:nvPr/>
+        </p:nvSpPr>
+        <p:spPr>
+          <a:xfrm>
+            <a:off x="5192744" y="5524500"/>
+            <a:ext cx="514826" cy="152400"/>
+          </a:xfrm>
+          <a:prstGeom prst="rect">
+            <a:avLst/>
+          </a:prstGeom>
+          <a:noFill/>
+          <a:ln/>
+        </p:spPr>
+        <p:txBody>
+          <a:bodyPr wrap="none" lIns="0" tIns="0" rIns="0" bIns="0" rtlCol="0" anchor="ctr"/>
+          <a:lstStyle/>
+          <a:p>
+            <a:pPr algn="l" indent="0" marL="0">
+              <a:buNone/>
+            </a:pPr>
+            <a:r>
+              <a:rPr lang="ko-KR" altLang="en-US" sz="1008" spc="-20" kern="0" dirty="0">
+                <a:solidFill>
+                  <a:srgbClr val="004B8D"/>
+                </a:solidFill>
+                <a:latin typeface="Paperlogy 7 Bold" pitchFamily="34" charset="0"/>
+                <a:ea typeface="Paperlogy 7 Bold" pitchFamily="34" charset="-127"/>
+                <a:cs typeface="Paperlogy 7 Bold" pitchFamily="34" charset="-120"/>
+              </a:rPr>
+              <a:t>주제 합의</a:t>
+            </a:r>
+            <a:endParaRPr lang="en-US" sz="1008" dirty="0"/>
+          </a:p>
+        </p:txBody>
+      </p:sp>
+      <p:sp>
+        <p:nvSpPr>
+          <p:cNvPr id="105" name="03"/>
+          <p:cNvSpPr txBox="1"/>
+          <p:nvPr/>
+        </p:nvSpPr>
+        <p:spPr>
+          <a:xfrm>
+            <a:off x="1499616" y="5969318"/>
             <a:ext cx="203930" cy="134112"/>
           </a:xfrm>
           <a:prstGeom prst="rect">
@@ -2749,7 +4061,7 @@
                 <a:ea typeface="Paperlogy 8 ExtraBold" pitchFamily="34" charset="-127"/>
                 <a:cs typeface="Paperlogy 8 ExtraBold" pitchFamily="34" charset="-120"/>
               </a:rPr>
-              <a:t>02</a:t>
+              <a:t>03</a:t>
             </a:r>
             <a:endParaRPr lang="en-US" sz="864" dirty="0"/>
           </a:p>
@@ -2757,14 +4069,14 @@
       </p:sp>
       <p:sp>
         <p:nvSpPr>
-          <p:cNvPr id="61" name="ALIGN"/>
-          <p:cNvSpPr txBox="1"/>
-          <p:nvPr/>
-        </p:nvSpPr>
-        <p:spPr>
-          <a:xfrm>
-            <a:off x="2459450" y="4424077"/>
-            <a:ext cx="495776" cy="134112"/>
+          <p:cNvPr id="106" name="ONE TEAM"/>
+          <p:cNvSpPr txBox="1"/>
+          <p:nvPr/>
+        </p:nvSpPr>
+        <p:spPr>
+          <a:xfrm>
+            <a:off x="1935194" y="5969318"/>
+            <a:ext cx="801624" cy="134112"/>
           </a:xfrm>
           <a:prstGeom prst="rect">
             <a:avLst/>
@@ -2788,7 +4100,7 @@
                 <a:ea typeface="Paperlogy 7 Bold" pitchFamily="34" charset="-127"/>
                 <a:cs typeface="Paperlogy 7 Bold" pitchFamily="34" charset="-120"/>
               </a:rPr>
-              <a:t>ALIGN</a:t>
+              <a:t>ONE TEAM</a:t>
             </a:r>
             <a:endParaRPr lang="en-US" sz="864" dirty="0"/>
           </a:p>
@@ -2796,14 +4108,14 @@
       </p:sp>
       <p:sp>
         <p:nvSpPr>
-          <p:cNvPr id="62" name="의견 조율 · 공통 기준 마련"/>
-          <p:cNvSpPr txBox="1"/>
-          <p:nvPr/>
-        </p:nvSpPr>
-        <p:spPr>
-          <a:xfrm>
-            <a:off x="2023872" y="4631912"/>
-            <a:ext cx="1699746" cy="188976"/>
+          <p:cNvPr id="107" name="강점 기반 역할 분담 · 지속적인 공유"/>
+          <p:cNvSpPr txBox="1"/>
+          <p:nvPr/>
+        </p:nvSpPr>
+        <p:spPr>
+          <a:xfrm>
+            <a:off x="1499616" y="6152769"/>
+            <a:ext cx="2326133" cy="188976"/>
           </a:xfrm>
           <a:prstGeom prst="rect">
             <a:avLst/>
@@ -2827,7 +4139,7 @@
                 <a:ea typeface="Paperlogy 7 Bold" pitchFamily="34" charset="-127"/>
                 <a:cs typeface="Paperlogy 7 Bold" pitchFamily="34" charset="-120"/>
               </a:rPr>
-              <a:t>의견 조율 · 공통 기준 마련</a:t>
+              <a:t>강점 기반 역할 분담 · 지속적인 공유</a:t>
             </a:r>
             <a:endParaRPr lang="en-US" sz="1296" dirty="0"/>
           </a:p>
@@ -2835,225 +4147,459 @@
       </p:sp>
       <p:sp>
         <p:nvSpPr>
-          <p:cNvPr id="63" name="경청 · 수상작 분석 · 교수님 조언"/>
-          <p:cNvSpPr txBox="1"/>
-          <p:nvPr/>
-        </p:nvSpPr>
-        <p:spPr>
-          <a:xfrm>
-            <a:off x="2304288" y="5063776"/>
-            <a:ext cx="1954380" cy="176784"/>
-          </a:xfrm>
-          <a:prstGeom prst="rect">
-            <a:avLst/>
-          </a:prstGeom>
-          <a:noFill/>
-          <a:ln/>
-        </p:spPr>
-        <p:txBody>
-          <a:bodyPr wrap="none" lIns="0" tIns="0" rIns="0" bIns="0" rtlCol="0" anchor="ctr"/>
-          <a:lstStyle/>
-          <a:p>
-            <a:pPr algn="l" indent="0" marL="0">
-              <a:buNone/>
-            </a:pPr>
-            <a:r>
-              <a:rPr lang="ko-KR" altLang="en-US" sz="1200" spc="-24" kern="0" dirty="0">
-                <a:solidFill>
-                  <a:srgbClr val="4B5568"/>
+          <p:cNvPr id="108" name="팀장"/>
+          <p:cNvSpPr txBox="1"/>
+          <p:nvPr/>
+        </p:nvSpPr>
+        <p:spPr>
+          <a:xfrm>
+            <a:off x="1877568" y="6543485"/>
+            <a:ext cx="307848" cy="176784"/>
+          </a:xfrm>
+          <a:prstGeom prst="rect">
+            <a:avLst/>
+          </a:prstGeom>
+          <a:noFill/>
+          <a:ln/>
+        </p:spPr>
+        <p:txBody>
+          <a:bodyPr wrap="none" lIns="0" tIns="0" rIns="0" bIns="0" rtlCol="0" anchor="ctr"/>
+          <a:lstStyle/>
+          <a:p>
+            <a:pPr algn="l" indent="0" marL="0">
+              <a:buNone/>
+            </a:pPr>
+            <a:r>
+              <a:rPr lang="ko-KR" altLang="en-US" sz="1200" spc="-36" kern="0" dirty="0">
+                <a:solidFill>
+                  <a:srgbClr val="0B2147"/>
+                </a:solidFill>
+                <a:latin typeface="Paperlogy 8 ExtraBold" pitchFamily="34" charset="0"/>
+                <a:ea typeface="Paperlogy 8 ExtraBold" pitchFamily="34" charset="-127"/>
+                <a:cs typeface="Paperlogy 8 ExtraBold" pitchFamily="34" charset="-120"/>
+              </a:rPr>
+              <a:t>팀장</a:t>
+            </a:r>
+            <a:endParaRPr lang="en-US" sz="1200" dirty="0"/>
+          </a:p>
+        </p:txBody>
+      </p:sp>
+      <p:sp>
+        <p:nvSpPr>
+          <p:cNvPr id="109" name="나"/>
+          <p:cNvSpPr txBox="1"/>
+          <p:nvPr/>
+        </p:nvSpPr>
+        <p:spPr>
+          <a:xfrm>
+            <a:off x="2264664" y="6568345"/>
+            <a:ext cx="144304" cy="134112"/>
+          </a:xfrm>
+          <a:prstGeom prst="rect">
+            <a:avLst/>
+          </a:prstGeom>
+          <a:noFill/>
+          <a:ln/>
+        </p:spPr>
+        <p:txBody>
+          <a:bodyPr wrap="none" lIns="0" tIns="0" rIns="0" bIns="0" rtlCol="0" anchor="ctr"/>
+          <a:lstStyle/>
+          <a:p>
+            <a:pPr algn="l" indent="0" marL="0">
+              <a:buNone/>
+            </a:pPr>
+            <a:r>
+              <a:rPr lang="ko-KR" altLang="en-US" sz="864" spc="-9" kern="0" dirty="0">
+                <a:solidFill>
+                  <a:srgbClr val="FFFFFF"/>
+                </a:solidFill>
+                <a:latin typeface="Paperlogy 7 Bold" pitchFamily="34" charset="0"/>
+                <a:ea typeface="Paperlogy 7 Bold" pitchFamily="34" charset="-127"/>
+                <a:cs typeface="Paperlogy 7 Bold" pitchFamily="34" charset="-120"/>
+              </a:rPr>
+              <a:t>나</a:t>
+            </a:r>
+            <a:endParaRPr lang="en-US" sz="864" dirty="0"/>
+          </a:p>
+        </p:txBody>
+      </p:sp>
+      <p:sp>
+        <p:nvSpPr>
+          <p:cNvPr id="110" name="프로젝트 총괄"/>
+          <p:cNvSpPr txBox="1"/>
+          <p:nvPr/>
+        </p:nvSpPr>
+        <p:spPr>
+          <a:xfrm>
+            <a:off x="1633728" y="6813233"/>
+            <a:ext cx="730472" cy="152400"/>
+          </a:xfrm>
+          <a:prstGeom prst="rect">
+            <a:avLst/>
+          </a:prstGeom>
+          <a:noFill/>
+          <a:ln/>
+        </p:spPr>
+        <p:txBody>
+          <a:bodyPr wrap="none" lIns="0" tIns="0" rIns="0" bIns="0" rtlCol="0" anchor="ctr"/>
+          <a:lstStyle/>
+          <a:p>
+            <a:pPr algn="l" indent="0" marL="0">
+              <a:buNone/>
+            </a:pPr>
+            <a:r>
+              <a:rPr lang="ko-KR" altLang="en-US" sz="1008" spc="-25" kern="0" dirty="0">
+                <a:solidFill>
+                  <a:srgbClr val="1C2536"/>
                 </a:solidFill>
                 <a:latin typeface="Paperlogy 6 SemiBold" pitchFamily="34" charset="0"/>
                 <a:ea typeface="Paperlogy 6 SemiBold" pitchFamily="34" charset="-127"/>
                 <a:cs typeface="Paperlogy 6 SemiBold" pitchFamily="34" charset="-120"/>
               </a:rPr>
-              <a:t>경청 · 수상작 분석 · 교수님 조언</a:t>
-            </a:r>
-            <a:endParaRPr lang="en-US" sz="1200" dirty="0"/>
-          </a:p>
-        </p:txBody>
-      </p:sp>
-      <p:sp>
-        <p:nvSpPr>
-          <p:cNvPr id="64" name="판단 기준 마련 → 방향 합의"/>
-          <p:cNvSpPr txBox="1"/>
-          <p:nvPr/>
-        </p:nvSpPr>
-        <p:spPr>
-          <a:xfrm>
-            <a:off x="4852416" y="5063776"/>
-            <a:ext cx="1655321" cy="176784"/>
-          </a:xfrm>
-          <a:prstGeom prst="rect">
-            <a:avLst/>
-          </a:prstGeom>
-          <a:noFill/>
-          <a:ln/>
-        </p:spPr>
-        <p:txBody>
-          <a:bodyPr wrap="none" lIns="0" tIns="0" rIns="0" bIns="0" rtlCol="0" anchor="ctr"/>
-          <a:lstStyle/>
-          <a:p>
-            <a:pPr algn="l" indent="0" marL="0">
-              <a:buNone/>
-            </a:pPr>
-            <a:r>
-              <a:rPr lang="ko-KR" altLang="en-US" sz="1200" spc="-24" kern="0" dirty="0">
-                <a:solidFill>
-                  <a:srgbClr val="4B5568"/>
+              <a:t>프로젝트 총괄</a:t>
+            </a:r>
+            <a:endParaRPr lang="en-US" sz="1008" dirty="0"/>
+          </a:p>
+        </p:txBody>
+      </p:sp>
+      <p:sp>
+        <p:nvSpPr>
+          <p:cNvPr id="111" name="기반 자동화 알고리즘 개발"/>
+          <p:cNvSpPr txBox="1"/>
+          <p:nvPr/>
+        </p:nvSpPr>
+        <p:spPr>
+          <a:xfrm>
+            <a:off x="2318290" y="7005257"/>
+            <a:ext cx="1355657" cy="152400"/>
+          </a:xfrm>
+          <a:prstGeom prst="rect">
+            <a:avLst/>
+          </a:prstGeom>
+          <a:noFill/>
+          <a:ln/>
+        </p:spPr>
+        <p:txBody>
+          <a:bodyPr wrap="none" lIns="0" tIns="0" rIns="0" bIns="0" rtlCol="0" anchor="ctr"/>
+          <a:lstStyle/>
+          <a:p>
+            <a:pPr algn="l" indent="0" marL="0">
+              <a:buNone/>
+            </a:pPr>
+            <a:r>
+              <a:rPr lang="ko-KR" altLang="en-US" sz="1008" spc="-25" kern="0" dirty="0">
+                <a:solidFill>
+                  <a:srgbClr val="1C2536"/>
                 </a:solidFill>
                 <a:latin typeface="Paperlogy 6 SemiBold" pitchFamily="34" charset="0"/>
                 <a:ea typeface="Paperlogy 6 SemiBold" pitchFamily="34" charset="-127"/>
                 <a:cs typeface="Paperlogy 6 SemiBold" pitchFamily="34" charset="-120"/>
               </a:rPr>
-              <a:t>판단 기준 마련 → 방향 합의</a:t>
-            </a:r>
-            <a:endParaRPr lang="en-US" sz="1200" dirty="0"/>
-          </a:p>
-        </p:txBody>
-      </p:sp>
-      <p:sp>
-        <p:nvSpPr>
-          <p:cNvPr id="65" name="03"/>
-          <p:cNvSpPr txBox="1"/>
-          <p:nvPr/>
-        </p:nvSpPr>
-        <p:spPr>
-          <a:xfrm>
-            <a:off x="2023872" y="6091904"/>
-            <a:ext cx="203930" cy="134112"/>
-          </a:xfrm>
-          <a:prstGeom prst="rect">
-            <a:avLst/>
-          </a:prstGeom>
-          <a:noFill/>
-          <a:ln/>
-        </p:spPr>
-        <p:txBody>
-          <a:bodyPr wrap="none" lIns="0" tIns="0" rIns="0" bIns="0" rtlCol="0" anchor="ctr"/>
-          <a:lstStyle/>
-          <a:p>
-            <a:pPr algn="l" indent="0" marL="0">
-              <a:buNone/>
-            </a:pPr>
-            <a:r>
-              <a:rPr lang="ko-KR" altLang="en-US" sz="864" spc="35" kern="0" dirty="0">
+              <a:t>기반 자동화 알고리즘 개발</a:t>
+            </a:r>
+            <a:endParaRPr lang="en-US" sz="1008" dirty="0"/>
+          </a:p>
+        </p:txBody>
+      </p:sp>
+      <p:sp>
+        <p:nvSpPr>
+          <p:cNvPr id="112" name="Dynamo"/>
+          <p:cNvSpPr txBox="1"/>
+          <p:nvPr/>
+        </p:nvSpPr>
+        <p:spPr>
+          <a:xfrm>
+            <a:off x="1706880" y="7017449"/>
+            <a:ext cx="537686" cy="134112"/>
+          </a:xfrm>
+          <a:prstGeom prst="rect">
+            <a:avLst/>
+          </a:prstGeom>
+          <a:noFill/>
+          <a:ln/>
+        </p:spPr>
+        <p:txBody>
+          <a:bodyPr wrap="none" lIns="0" tIns="0" rIns="0" bIns="0" rtlCol="0" anchor="ctr"/>
+          <a:lstStyle/>
+          <a:p>
+            <a:pPr algn="l" indent="0" marL="0">
+              <a:buNone/>
+            </a:pPr>
+            <a:r>
+              <a:rPr lang="ko-KR" altLang="en-US" sz="864" dirty="0">
                 <a:solidFill>
                   <a:srgbClr val="004B8D"/>
+                </a:solidFill>
+                <a:latin typeface="Paperlogy 7 Bold" pitchFamily="34" charset="0"/>
+                <a:ea typeface="Paperlogy 7 Bold" pitchFamily="34" charset="-127"/>
+                <a:cs typeface="Paperlogy 7 Bold" pitchFamily="34" charset="-120"/>
+              </a:rPr>
+              <a:t>Dynamo</a:t>
+            </a:r>
+            <a:endParaRPr lang="en-US" sz="864" dirty="0"/>
+          </a:p>
+        </p:txBody>
+      </p:sp>
+      <p:sp>
+        <p:nvSpPr>
+          <p:cNvPr id="113" name="팀원 A"/>
+          <p:cNvSpPr txBox="1"/>
+          <p:nvPr/>
+        </p:nvSpPr>
+        <p:spPr>
+          <a:xfrm>
+            <a:off x="4700016" y="6543485"/>
+            <a:ext cx="450437" cy="176784"/>
+          </a:xfrm>
+          <a:prstGeom prst="rect">
+            <a:avLst/>
+          </a:prstGeom>
+          <a:noFill/>
+          <a:ln/>
+        </p:spPr>
+        <p:txBody>
+          <a:bodyPr wrap="none" lIns="0" tIns="0" rIns="0" bIns="0" rtlCol="0" anchor="ctr"/>
+          <a:lstStyle/>
+          <a:p>
+            <a:pPr algn="l" indent="0" marL="0">
+              <a:buNone/>
+            </a:pPr>
+            <a:r>
+              <a:rPr lang="ko-KR" altLang="en-US" sz="1200" spc="-36" kern="0" dirty="0">
+                <a:solidFill>
+                  <a:srgbClr val="0B2147"/>
                 </a:solidFill>
                 <a:latin typeface="Paperlogy 8 ExtraBold" pitchFamily="34" charset="0"/>
                 <a:ea typeface="Paperlogy 8 ExtraBold" pitchFamily="34" charset="-127"/>
                 <a:cs typeface="Paperlogy 8 ExtraBold" pitchFamily="34" charset="-120"/>
               </a:rPr>
-              <a:t>03</a:t>
-            </a:r>
-            <a:endParaRPr lang="en-US" sz="864" dirty="0"/>
-          </a:p>
-        </p:txBody>
-      </p:sp>
-      <p:sp>
-        <p:nvSpPr>
-          <p:cNvPr id="66" name="ONE TEAM"/>
-          <p:cNvSpPr txBox="1"/>
-          <p:nvPr/>
-        </p:nvSpPr>
-        <p:spPr>
-          <a:xfrm>
-            <a:off x="2459450" y="6091904"/>
-            <a:ext cx="801624" cy="134112"/>
-          </a:xfrm>
-          <a:prstGeom prst="rect">
-            <a:avLst/>
-          </a:prstGeom>
-          <a:noFill/>
-          <a:ln/>
-        </p:spPr>
-        <p:txBody>
-          <a:bodyPr wrap="none" lIns="0" tIns="0" rIns="0" bIns="0" rtlCol="0" anchor="ctr"/>
-          <a:lstStyle/>
-          <a:p>
-            <a:pPr algn="l" indent="0" marL="0">
-              <a:buNone/>
-            </a:pPr>
-            <a:r>
-              <a:rPr lang="ko-KR" altLang="en-US" sz="864" spc="138" kern="0" dirty="0">
-                <a:solidFill>
-                  <a:srgbClr val="2A78DD"/>
+              <a:t>팀원 A</a:t>
+            </a:r>
+            <a:endParaRPr lang="en-US" sz="1200" dirty="0"/>
+          </a:p>
+        </p:txBody>
+      </p:sp>
+      <p:sp>
+        <p:nvSpPr>
+          <p:cNvPr id="114" name="유닛 모듈러 설계"/>
+          <p:cNvSpPr txBox="1"/>
+          <p:nvPr/>
+        </p:nvSpPr>
+        <p:spPr>
+          <a:xfrm>
+            <a:off x="4456176" y="6813233"/>
+            <a:ext cx="865068" cy="152400"/>
+          </a:xfrm>
+          <a:prstGeom prst="rect">
+            <a:avLst/>
+          </a:prstGeom>
+          <a:noFill/>
+          <a:ln/>
+        </p:spPr>
+        <p:txBody>
+          <a:bodyPr wrap="none" lIns="0" tIns="0" rIns="0" bIns="0" rtlCol="0" anchor="ctr"/>
+          <a:lstStyle/>
+          <a:p>
+            <a:pPr algn="l" indent="0" marL="0">
+              <a:buNone/>
+            </a:pPr>
+            <a:r>
+              <a:rPr lang="ko-KR" altLang="en-US" sz="1008" spc="-25" kern="0" dirty="0">
+                <a:solidFill>
+                  <a:srgbClr val="4B5568"/>
+                </a:solidFill>
+                <a:latin typeface="Paperlogy 6 SemiBold" pitchFamily="34" charset="0"/>
+                <a:ea typeface="Paperlogy 6 SemiBold" pitchFamily="34" charset="-127"/>
+                <a:cs typeface="Paperlogy 6 SemiBold" pitchFamily="34" charset="-120"/>
+              </a:rPr>
+              <a:t>유닛 모듈러 설계</a:t>
+            </a:r>
+            <a:endParaRPr lang="en-US" sz="1008" dirty="0"/>
+          </a:p>
+        </p:txBody>
+      </p:sp>
+      <p:sp>
+        <p:nvSpPr>
+          <p:cNvPr id="115" name="배치계획"/>
+          <p:cNvSpPr txBox="1"/>
+          <p:nvPr/>
+        </p:nvSpPr>
+        <p:spPr>
+          <a:xfrm>
+            <a:off x="4456176" y="7005257"/>
+            <a:ext cx="486632" cy="152400"/>
+          </a:xfrm>
+          <a:prstGeom prst="rect">
+            <a:avLst/>
+          </a:prstGeom>
+          <a:noFill/>
+          <a:ln/>
+        </p:spPr>
+        <p:txBody>
+          <a:bodyPr wrap="none" lIns="0" tIns="0" rIns="0" bIns="0" rtlCol="0" anchor="ctr"/>
+          <a:lstStyle/>
+          <a:p>
+            <a:pPr algn="l" indent="0" marL="0">
+              <a:buNone/>
+            </a:pPr>
+            <a:r>
+              <a:rPr lang="ko-KR" altLang="en-US" sz="1008" spc="-25" kern="0" dirty="0">
+                <a:solidFill>
+                  <a:srgbClr val="4B5568"/>
+                </a:solidFill>
+                <a:latin typeface="Paperlogy 6 SemiBold" pitchFamily="34" charset="0"/>
+                <a:ea typeface="Paperlogy 6 SemiBold" pitchFamily="34" charset="-127"/>
+                <a:cs typeface="Paperlogy 6 SemiBold" pitchFamily="34" charset="-120"/>
+              </a:rPr>
+              <a:t>배치계획</a:t>
+            </a:r>
+            <a:endParaRPr lang="en-US" sz="1008" dirty="0"/>
+          </a:p>
+        </p:txBody>
+      </p:sp>
+      <p:sp>
+        <p:nvSpPr>
+          <p:cNvPr id="116" name="이틀마다 진행상황 공유 · 피드백"/>
+          <p:cNvSpPr txBox="1"/>
+          <p:nvPr/>
+        </p:nvSpPr>
+        <p:spPr>
+          <a:xfrm>
+            <a:off x="3566351" y="7354443"/>
+            <a:ext cx="1666730" cy="152400"/>
+          </a:xfrm>
+          <a:prstGeom prst="rect">
+            <a:avLst/>
+          </a:prstGeom>
+          <a:noFill/>
+          <a:ln/>
+        </p:spPr>
+        <p:txBody>
+          <a:bodyPr wrap="none" lIns="0" tIns="0" rIns="0" bIns="0" rtlCol="0" anchor="ctr"/>
+          <a:lstStyle/>
+          <a:p>
+            <a:pPr algn="l" indent="0" marL="0">
+              <a:buNone/>
+            </a:pPr>
+            <a:r>
+              <a:rPr lang="ko-KR" altLang="en-US" sz="1008" spc="-20" kern="0" dirty="0">
+                <a:solidFill>
+                  <a:srgbClr val="0B6B33"/>
                 </a:solidFill>
                 <a:latin typeface="Paperlogy 7 Bold" pitchFamily="34" charset="0"/>
                 <a:ea typeface="Paperlogy 7 Bold" pitchFamily="34" charset="-127"/>
                 <a:cs typeface="Paperlogy 7 Bold" pitchFamily="34" charset="-120"/>
               </a:rPr>
-              <a:t>ONE TEAM</a:t>
-            </a:r>
-            <a:endParaRPr lang="en-US" sz="864" dirty="0"/>
-          </a:p>
-        </p:txBody>
-      </p:sp>
-      <p:sp>
-        <p:nvSpPr>
-          <p:cNvPr id="67" name="역할 분담 · 지속적인 공유"/>
-          <p:cNvSpPr txBox="1"/>
-          <p:nvPr/>
-        </p:nvSpPr>
-        <p:spPr>
-          <a:xfrm>
-            <a:off x="2023872" y="6299740"/>
-            <a:ext cx="1666629" cy="188976"/>
-          </a:xfrm>
-          <a:prstGeom prst="rect">
-            <a:avLst/>
-          </a:prstGeom>
-          <a:noFill/>
-          <a:ln/>
-        </p:spPr>
-        <p:txBody>
-          <a:bodyPr wrap="none" lIns="0" tIns="0" rIns="0" bIns="0" rtlCol="0" anchor="ctr"/>
-          <a:lstStyle/>
-          <a:p>
-            <a:pPr algn="l" indent="0" marL="0">
-              <a:buNone/>
-            </a:pPr>
-            <a:r>
-              <a:rPr lang="ko-KR" altLang="en-US" sz="1296" spc="-39" kern="0" dirty="0">
+              <a:t>이틀마다 진행상황 공유 · 피드백</a:t>
+            </a:r>
+            <a:endParaRPr lang="en-US" sz="1008" dirty="0"/>
+          </a:p>
+        </p:txBody>
+      </p:sp>
+      <p:sp>
+        <p:nvSpPr>
+          <p:cNvPr id="117" name="팀원 B"/>
+          <p:cNvSpPr txBox="1"/>
+          <p:nvPr/>
+        </p:nvSpPr>
+        <p:spPr>
+          <a:xfrm>
+            <a:off x="1877568" y="7709345"/>
+            <a:ext cx="450342" cy="176784"/>
+          </a:xfrm>
+          <a:prstGeom prst="rect">
+            <a:avLst/>
+          </a:prstGeom>
+          <a:noFill/>
+          <a:ln/>
+        </p:spPr>
+        <p:txBody>
+          <a:bodyPr wrap="none" lIns="0" tIns="0" rIns="0" bIns="0" rtlCol="0" anchor="ctr"/>
+          <a:lstStyle/>
+          <a:p>
+            <a:pPr algn="l" indent="0" marL="0">
+              <a:buNone/>
+            </a:pPr>
+            <a:r>
+              <a:rPr lang="ko-KR" altLang="en-US" sz="1200" spc="-36" kern="0" dirty="0">
                 <a:solidFill>
                   <a:srgbClr val="0B2147"/>
+                </a:solidFill>
+                <a:latin typeface="Paperlogy 8 ExtraBold" pitchFamily="34" charset="0"/>
+                <a:ea typeface="Paperlogy 8 ExtraBold" pitchFamily="34" charset="-127"/>
+                <a:cs typeface="Paperlogy 8 ExtraBold" pitchFamily="34" charset="-120"/>
+              </a:rPr>
+              <a:t>팀원 B</a:t>
+            </a:r>
+            <a:endParaRPr lang="en-US" sz="1200" dirty="0"/>
+          </a:p>
+        </p:txBody>
+      </p:sp>
+      <p:sp>
+        <p:nvSpPr>
+          <p:cNvPr id="118" name="Revit"/>
+          <p:cNvSpPr txBox="1"/>
+          <p:nvPr/>
+        </p:nvSpPr>
+        <p:spPr>
+          <a:xfrm>
+            <a:off x="1706880" y="7991285"/>
+            <a:ext cx="340709" cy="134112"/>
+          </a:xfrm>
+          <a:prstGeom prst="rect">
+            <a:avLst/>
+          </a:prstGeom>
+          <a:noFill/>
+          <a:ln/>
+        </p:spPr>
+        <p:txBody>
+          <a:bodyPr wrap="none" lIns="0" tIns="0" rIns="0" bIns="0" rtlCol="0" anchor="ctr"/>
+          <a:lstStyle/>
+          <a:p>
+            <a:pPr algn="l" indent="0" marL="0">
+              <a:buNone/>
+            </a:pPr>
+            <a:r>
+              <a:rPr lang="ko-KR" altLang="en-US" sz="864" dirty="0">
+                <a:solidFill>
+                  <a:srgbClr val="004B8D"/>
                 </a:solidFill>
                 <a:latin typeface="Paperlogy 7 Bold" pitchFamily="34" charset="0"/>
                 <a:ea typeface="Paperlogy 7 Bold" pitchFamily="34" charset="-127"/>
                 <a:cs typeface="Paperlogy 7 Bold" pitchFamily="34" charset="-120"/>
               </a:rPr>
-              <a:t>역할 분담 · 지속적인 공유</a:t>
-            </a:r>
-            <a:endParaRPr lang="en-US" sz="1296" dirty="0"/>
-          </a:p>
-        </p:txBody>
-      </p:sp>
-      <p:sp>
-        <p:nvSpPr>
-          <p:cNvPr id="68" name="강점 기반 역할 분담"/>
-          <p:cNvSpPr txBox="1"/>
-          <p:nvPr/>
-        </p:nvSpPr>
-        <p:spPr>
-          <a:xfrm>
-            <a:off x="2304288" y="6731603"/>
-            <a:ext cx="1208349" cy="176784"/>
-          </a:xfrm>
-          <a:prstGeom prst="rect">
-            <a:avLst/>
-          </a:prstGeom>
-          <a:noFill/>
-          <a:ln/>
-        </p:spPr>
-        <p:txBody>
-          <a:bodyPr wrap="none" lIns="0" tIns="0" rIns="0" bIns="0" rtlCol="0" anchor="ctr"/>
-          <a:lstStyle/>
-          <a:p>
-            <a:pPr algn="l" indent="0" marL="0">
-              <a:buNone/>
-            </a:pPr>
-            <a:r>
-              <a:rPr lang="ko-KR" altLang="en-US" sz="1200" spc="-24" kern="0" dirty="0">
+              <a:t>Revit</a:t>
+            </a:r>
+            <a:endParaRPr lang="en-US" sz="864" dirty="0"/>
+          </a:p>
+        </p:txBody>
+      </p:sp>
+      <p:sp>
+        <p:nvSpPr>
+          <p:cNvPr id="119" name="기반 BIM 모델링"/>
+          <p:cNvSpPr txBox="1"/>
+          <p:nvPr/>
+        </p:nvSpPr>
+        <p:spPr>
+          <a:xfrm>
+            <a:off x="2121313" y="7979093"/>
+            <a:ext cx="898790" cy="152400"/>
+          </a:xfrm>
+          <a:prstGeom prst="rect">
+            <a:avLst/>
+          </a:prstGeom>
+          <a:noFill/>
+          <a:ln/>
+        </p:spPr>
+        <p:txBody>
+          <a:bodyPr wrap="none" lIns="0" tIns="0" rIns="0" bIns="0" rtlCol="0" anchor="ctr"/>
+          <a:lstStyle/>
+          <a:p>
+            <a:pPr algn="l" indent="0" marL="0">
+              <a:buNone/>
+            </a:pPr>
+            <a:r>
+              <a:rPr lang="ko-KR" altLang="en-US" sz="1008" spc="-25" kern="0" dirty="0">
                 <a:solidFill>
                   <a:srgbClr val="4B5568"/>
                 </a:solidFill>
@@ -3061,38 +4607,38 @@
                 <a:ea typeface="Paperlogy 6 SemiBold" pitchFamily="34" charset="-127"/>
                 <a:cs typeface="Paperlogy 6 SemiBold" pitchFamily="34" charset="-120"/>
               </a:rPr>
-              <a:t>강점 기반 역할 분담</a:t>
-            </a:r>
-            <a:endParaRPr lang="en-US" sz="1200" dirty="0"/>
-          </a:p>
-        </p:txBody>
-      </p:sp>
-      <p:sp>
-        <p:nvSpPr>
-          <p:cNvPr id="69" name="이틀마다 진행상황 공유 · 피드백"/>
-          <p:cNvSpPr txBox="1"/>
-          <p:nvPr/>
-        </p:nvSpPr>
-        <p:spPr>
-          <a:xfrm>
-            <a:off x="4852416" y="6731603"/>
-            <a:ext cx="1982044" cy="176784"/>
-          </a:xfrm>
-          <a:prstGeom prst="rect">
-            <a:avLst/>
-          </a:prstGeom>
-          <a:noFill/>
-          <a:ln/>
-        </p:spPr>
-        <p:txBody>
-          <a:bodyPr wrap="none" lIns="0" tIns="0" rIns="0" bIns="0" rtlCol="0" anchor="ctr"/>
-          <a:lstStyle/>
-          <a:p>
-            <a:pPr algn="l" indent="0" marL="0">
-              <a:buNone/>
-            </a:pPr>
-            <a:r>
-              <a:rPr lang="ko-KR" altLang="en-US" sz="1200" spc="-24" kern="0" dirty="0">
+              <a:t>기반 BIM 모델링</a:t>
+            </a:r>
+            <a:endParaRPr lang="en-US" sz="1008" dirty="0"/>
+          </a:p>
+        </p:txBody>
+      </p:sp>
+      <p:sp>
+        <p:nvSpPr>
+          <p:cNvPr id="120" name="데이터 구축"/>
+          <p:cNvSpPr txBox="1"/>
+          <p:nvPr/>
+        </p:nvSpPr>
+        <p:spPr>
+          <a:xfrm>
+            <a:off x="1633728" y="8171117"/>
+            <a:ext cx="621030" cy="152400"/>
+          </a:xfrm>
+          <a:prstGeom prst="rect">
+            <a:avLst/>
+          </a:prstGeom>
+          <a:noFill/>
+          <a:ln/>
+        </p:spPr>
+        <p:txBody>
+          <a:bodyPr wrap="none" lIns="0" tIns="0" rIns="0" bIns="0" rtlCol="0" anchor="ctr"/>
+          <a:lstStyle/>
+          <a:p>
+            <a:pPr algn="l" indent="0" marL="0">
+              <a:buNone/>
+            </a:pPr>
+            <a:r>
+              <a:rPr lang="ko-KR" altLang="en-US" sz="1008" spc="-25" kern="0" dirty="0">
                 <a:solidFill>
                   <a:srgbClr val="4B5568"/>
                 </a:solidFill>
@@ -3100,38 +4646,38 @@
                 <a:ea typeface="Paperlogy 6 SemiBold" pitchFamily="34" charset="-127"/>
                 <a:cs typeface="Paperlogy 6 SemiBold" pitchFamily="34" charset="-120"/>
               </a:rPr>
-              <a:t>이틀마다 진행상황 공유 · 피드백</a:t>
-            </a:r>
-            <a:endParaRPr lang="en-US" sz="1200" dirty="0"/>
-          </a:p>
-        </p:txBody>
-      </p:sp>
-      <p:sp>
-        <p:nvSpPr>
-          <p:cNvPr id="70" name="장려상"/>
-          <p:cNvSpPr txBox="1"/>
-          <p:nvPr/>
-        </p:nvSpPr>
-        <p:spPr>
-          <a:xfrm>
-            <a:off x="1266587" y="8145304"/>
-            <a:ext cx="331946" cy="134112"/>
-          </a:xfrm>
-          <a:prstGeom prst="rect">
-            <a:avLst/>
-          </a:prstGeom>
-          <a:noFill/>
-          <a:ln/>
-        </p:spPr>
-        <p:txBody>
-          <a:bodyPr wrap="none" lIns="0" tIns="0" rIns="0" bIns="0" rtlCol="0" anchor="ctr"/>
-          <a:lstStyle/>
-          <a:p>
-            <a:pPr algn="ctr" indent="0" marL="0">
-              <a:buNone/>
-            </a:pPr>
-            <a:r>
-              <a:rPr lang="ko-KR" altLang="en-US" sz="864" spc="-17" kern="0" dirty="0">
+              <a:t>데이터 구축</a:t>
+            </a:r>
+            <a:endParaRPr lang="en-US" sz="1008" dirty="0"/>
+          </a:p>
+        </p:txBody>
+      </p:sp>
+      <p:sp>
+        <p:nvSpPr>
+          <p:cNvPr id="121" name="팀원 C"/>
+          <p:cNvSpPr txBox="1"/>
+          <p:nvPr/>
+        </p:nvSpPr>
+        <p:spPr>
+          <a:xfrm>
+            <a:off x="4700016" y="7709345"/>
+            <a:ext cx="445008" cy="176784"/>
+          </a:xfrm>
+          <a:prstGeom prst="rect">
+            <a:avLst/>
+          </a:prstGeom>
+          <a:noFill/>
+          <a:ln/>
+        </p:spPr>
+        <p:txBody>
+          <a:bodyPr wrap="none" lIns="0" tIns="0" rIns="0" bIns="0" rtlCol="0" anchor="ctr"/>
+          <a:lstStyle/>
+          <a:p>
+            <a:pPr algn="l" indent="0" marL="0">
+              <a:buNone/>
+            </a:pPr>
+            <a:r>
+              <a:rPr lang="ko-KR" altLang="en-US" sz="1200" spc="-36" kern="0" dirty="0">
                 <a:solidFill>
                   <a:srgbClr val="0B2147"/>
                 </a:solidFill>
@@ -3139,45 +4685,162 @@
                 <a:ea typeface="Paperlogy 8 ExtraBold" pitchFamily="34" charset="-127"/>
                 <a:cs typeface="Paperlogy 8 ExtraBold" pitchFamily="34" charset="-120"/>
               </a:rPr>
-              <a:t>장려상</a:t>
-            </a:r>
-            <a:endParaRPr lang="en-US" sz="864" dirty="0"/>
-          </a:p>
-        </p:txBody>
-      </p:sp>
-      <p:sp>
-        <p:nvSpPr>
-          <p:cNvPr id="71" name="04"/>
-          <p:cNvSpPr txBox="1"/>
-          <p:nvPr/>
-        </p:nvSpPr>
-        <p:spPr>
-          <a:xfrm>
-            <a:off x="2023872" y="7759732"/>
-            <a:ext cx="203930" cy="134112"/>
-          </a:xfrm>
-          <a:prstGeom prst="rect">
-            <a:avLst/>
-          </a:prstGeom>
-          <a:noFill/>
-          <a:ln/>
-        </p:spPr>
-        <p:txBody>
-          <a:bodyPr wrap="none" lIns="0" tIns="0" rIns="0" bIns="0" rtlCol="0" anchor="ctr"/>
-          <a:lstStyle/>
-          <a:p>
-            <a:pPr algn="l" indent="0" marL="0">
-              <a:buNone/>
-            </a:pPr>
-            <a:r>
-              <a:rPr lang="ko-KR" altLang="en-US" sz="864" spc="35" kern="0" dirty="0">
-                <a:solidFill>
-                  <a:srgbClr val="004B8D"/>
+              <a:t>팀원 C</a:t>
+            </a:r>
+            <a:endParaRPr lang="en-US" sz="1200" dirty="0"/>
+          </a:p>
+        </p:txBody>
+      </p:sp>
+      <p:sp>
+        <p:nvSpPr>
+          <p:cNvPr id="122" name="리모델링 적용 시나리오 구성"/>
+          <p:cNvSpPr txBox="1"/>
+          <p:nvPr/>
+        </p:nvSpPr>
+        <p:spPr>
+          <a:xfrm>
+            <a:off x="4456176" y="7979093"/>
+            <a:ext cx="1471666" cy="152400"/>
+          </a:xfrm>
+          <a:prstGeom prst="rect">
+            <a:avLst/>
+          </a:prstGeom>
+          <a:noFill/>
+          <a:ln/>
+        </p:spPr>
+        <p:txBody>
+          <a:bodyPr wrap="none" lIns="0" tIns="0" rIns="0" bIns="0" rtlCol="0" anchor="ctr"/>
+          <a:lstStyle/>
+          <a:p>
+            <a:pPr algn="l" indent="0" marL="0">
+              <a:buNone/>
+            </a:pPr>
+            <a:r>
+              <a:rPr lang="ko-KR" altLang="en-US" sz="1008" spc="-25" kern="0" dirty="0">
+                <a:solidFill>
+                  <a:srgbClr val="4B5568"/>
+                </a:solidFill>
+                <a:latin typeface="Paperlogy 6 SemiBold" pitchFamily="34" charset="0"/>
+                <a:ea typeface="Paperlogy 6 SemiBold" pitchFamily="34" charset="-127"/>
+                <a:cs typeface="Paperlogy 6 SemiBold" pitchFamily="34" charset="-120"/>
+              </a:rPr>
+              <a:t>리모델링 적용 시나리오 구성</a:t>
+            </a:r>
+            <a:endParaRPr lang="en-US" sz="1008" dirty="0"/>
+          </a:p>
+        </p:txBody>
+      </p:sp>
+      <p:sp>
+        <p:nvSpPr>
+          <p:cNvPr id="123" name="시연 영상 제작"/>
+          <p:cNvSpPr txBox="1"/>
+          <p:nvPr/>
+        </p:nvSpPr>
+        <p:spPr>
+          <a:xfrm>
+            <a:off x="4456176" y="8171117"/>
+            <a:ext cx="755428" cy="152400"/>
+          </a:xfrm>
+          <a:prstGeom prst="rect">
+            <a:avLst/>
+          </a:prstGeom>
+          <a:noFill/>
+          <a:ln/>
+        </p:spPr>
+        <p:txBody>
+          <a:bodyPr wrap="none" lIns="0" tIns="0" rIns="0" bIns="0" rtlCol="0" anchor="ctr"/>
+          <a:lstStyle/>
+          <a:p>
+            <a:pPr algn="l" indent="0" marL="0">
+              <a:buNone/>
+            </a:pPr>
+            <a:r>
+              <a:rPr lang="ko-KR" altLang="en-US" sz="1008" spc="-25" kern="0" dirty="0">
+                <a:solidFill>
+                  <a:srgbClr val="4B5568"/>
+                </a:solidFill>
+                <a:latin typeface="Paperlogy 6 SemiBold" pitchFamily="34" charset="0"/>
+                <a:ea typeface="Paperlogy 6 SemiBold" pitchFamily="34" charset="-127"/>
+                <a:cs typeface="Paperlogy 6 SemiBold" pitchFamily="34" charset="-120"/>
+              </a:rPr>
+              <a:t>시연 영상 제작</a:t>
+            </a:r>
+            <a:endParaRPr lang="en-US" sz="1008" dirty="0"/>
+          </a:p>
+        </p:txBody>
+      </p:sp>
+      <p:sp>
+        <p:nvSpPr>
+          <p:cNvPr id="124" name="장려상"/>
+          <p:cNvSpPr txBox="1"/>
+          <p:nvPr/>
+        </p:nvSpPr>
+        <p:spPr>
+          <a:xfrm>
+            <a:off x="865061" y="8922115"/>
+            <a:ext cx="328613" cy="134112"/>
+          </a:xfrm>
+          <a:prstGeom prst="rect">
+            <a:avLst/>
+          </a:prstGeom>
+          <a:noFill/>
+          <a:ln/>
+        </p:spPr>
+        <p:txBody>
+          <a:bodyPr wrap="none" lIns="0" tIns="0" rIns="0" bIns="0" rtlCol="0" anchor="ctr"/>
+          <a:lstStyle/>
+          <a:p>
+            <a:pPr algn="ctr" indent="0" marL="0">
+              <a:buNone/>
+            </a:pPr>
+            <a:r>
+              <a:rPr lang="ko-KR" altLang="en-US" sz="864" spc="-26" kern="0" dirty="0">
+                <a:solidFill>
+                  <a:srgbClr val="0B2147"/>
                 </a:solidFill>
                 <a:latin typeface="Paperlogy 8 ExtraBold" pitchFamily="34" charset="0"/>
                 <a:ea typeface="Paperlogy 8 ExtraBold" pitchFamily="34" charset="-127"/>
                 <a:cs typeface="Paperlogy 8 ExtraBold" pitchFamily="34" charset="-120"/>
               </a:rPr>
+              <a:t>장려상</a:t>
+            </a:r>
+            <a:endParaRPr lang="en-US" sz="864" dirty="0"/>
+          </a:p>
+        </p:txBody>
+      </p:sp>
+      <p:sp>
+        <p:nvSpPr>
+          <p:cNvPr id="125" name="04"/>
+          <p:cNvSpPr txBox="1"/>
+          <p:nvPr/>
+        </p:nvSpPr>
+        <p:spPr>
+          <a:xfrm>
+            <a:off x="1499616" y="8666417"/>
+            <a:ext cx="203930" cy="134112"/>
+          </a:xfrm>
+          <a:prstGeom prst="rect">
+            <a:avLst/>
+          </a:prstGeom>
+          <a:noFill/>
+          <a:ln/>
+        </p:spPr>
+        <p:txBody>
+          <a:bodyPr wrap="none" lIns="0" tIns="0" rIns="0" bIns="0" rtlCol="0" anchor="ctr"/>
+          <a:lstStyle/>
+          <a:p>
+            <a:pPr algn="l" indent="0" marL="0">
+              <a:buNone/>
+            </a:pPr>
+            <a:r>
+              <a:rPr lang="ko-KR" altLang="en-US" sz="864" spc="35" kern="0" dirty="0">
+                <a:solidFill>
+                  <a:srgbClr val="004B8D"/>
+                </a:solidFill>
+                <a:latin typeface="Paperlogy 8 ExtraBold" pitchFamily="34" charset="0"/>
+                <a:ea typeface="Paperlogy 8 ExtraBold" pitchFamily="34" charset="-127"/>
+                <a:cs typeface="Paperlogy 8 ExtraBold" pitchFamily="34" charset="-120"/>
+              </a:rPr>
               <a:t>04</a:t>
             </a:r>
             <a:endParaRPr lang="en-US" sz="864" dirty="0"/>
@@ -3186,13 +4849,13 @@
       </p:sp>
       <p:sp>
         <p:nvSpPr>
-          <p:cNvPr id="72" name="RESULT"/>
-          <p:cNvSpPr txBox="1"/>
-          <p:nvPr/>
-        </p:nvSpPr>
-        <p:spPr>
-          <a:xfrm>
-            <a:off x="2459450" y="7759732"/>
+          <p:cNvPr id="126" name="RESULT"/>
+          <p:cNvSpPr txBox="1"/>
+          <p:nvPr/>
+        </p:nvSpPr>
+        <p:spPr>
+          <a:xfrm>
+            <a:off x="1935194" y="8666417"/>
             <a:ext cx="590360" cy="134112"/>
           </a:xfrm>
           <a:prstGeom prst="rect">
@@ -3225,13 +4888,13 @@
       </p:sp>
       <p:sp>
         <p:nvSpPr>
-          <p:cNvPr id="73" name="프로젝트 완성 · 장려상 수상"/>
-          <p:cNvSpPr txBox="1"/>
-          <p:nvPr/>
-        </p:nvSpPr>
-        <p:spPr>
-          <a:xfrm>
-            <a:off x="2023872" y="7967567"/>
+          <p:cNvPr id="127" name="프로젝트 완성 · 장려상 수상"/>
+          <p:cNvSpPr txBox="1"/>
+          <p:nvPr/>
+        </p:nvSpPr>
+        <p:spPr>
+          <a:xfrm>
+            <a:off x="1499616" y="8849868"/>
             <a:ext cx="1814947" cy="188976"/>
           </a:xfrm>
           <a:prstGeom prst="rect">
@@ -3264,30 +4927,30 @@
       </p:sp>
       <p:sp>
         <p:nvSpPr>
-          <p:cNvPr id="74" name="남은 3주 내 프로젝트 완수"/>
-          <p:cNvSpPr txBox="1"/>
-          <p:nvPr/>
-        </p:nvSpPr>
-        <p:spPr>
-          <a:xfrm>
-            <a:off x="2304288" y="8399431"/>
-            <a:ext cx="1623012" cy="176784"/>
-          </a:xfrm>
-          <a:prstGeom prst="rect">
-            <a:avLst/>
-          </a:prstGeom>
-          <a:noFill/>
-          <a:ln/>
-        </p:spPr>
-        <p:txBody>
-          <a:bodyPr wrap="none" lIns="0" tIns="0" rIns="0" bIns="0" rtlCol="0" anchor="ctr"/>
-          <a:lstStyle/>
-          <a:p>
-            <a:pPr algn="l" indent="0" marL="0">
-              <a:buNone/>
-            </a:pPr>
-            <a:r>
-              <a:rPr lang="ko-KR" altLang="en-US" sz="1200" spc="-24" kern="0" dirty="0">
+          <p:cNvPr id="128" name="남은 3주 내 시연 영상 완성"/>
+          <p:cNvSpPr txBox="1"/>
+          <p:nvPr/>
+        </p:nvSpPr>
+        <p:spPr>
+          <a:xfrm>
+            <a:off x="1804416" y="9172194"/>
+            <a:ext cx="1390490" cy="152400"/>
+          </a:xfrm>
+          <a:prstGeom prst="rect">
+            <a:avLst/>
+          </a:prstGeom>
+          <a:noFill/>
+          <a:ln/>
+        </p:spPr>
+        <p:txBody>
+          <a:bodyPr wrap="none" lIns="0" tIns="0" rIns="0" bIns="0" rtlCol="0" anchor="ctr"/>
+          <a:lstStyle/>
+          <a:p>
+            <a:pPr algn="l" indent="0" marL="0">
+              <a:buNone/>
+            </a:pPr>
+            <a:r>
+              <a:rPr lang="ko-KR" altLang="en-US" sz="1008" spc="-20" kern="0" dirty="0">
                 <a:solidFill>
                   <a:srgbClr val="8A5A00"/>
                 </a:solidFill>
@@ -3295,38 +4958,38 @@
                 <a:ea typeface="Paperlogy 7 Bold" pitchFamily="34" charset="-127"/>
                 <a:cs typeface="Paperlogy 7 Bold" pitchFamily="34" charset="-120"/>
               </a:rPr>
-              <a:t>남은 3주 내 프로젝트 완수</a:t>
-            </a:r>
-            <a:endParaRPr lang="en-US" sz="1200" dirty="0"/>
-          </a:p>
-        </p:txBody>
-      </p:sp>
-      <p:sp>
-        <p:nvSpPr>
-          <p:cNvPr id="75" name="학생 BIM 경진대회 장려상"/>
-          <p:cNvSpPr txBox="1"/>
-          <p:nvPr/>
-        </p:nvSpPr>
-        <p:spPr>
-          <a:xfrm>
-            <a:off x="4852416" y="8399431"/>
-            <a:ext cx="1668447" cy="176784"/>
-          </a:xfrm>
-          <a:prstGeom prst="rect">
-            <a:avLst/>
-          </a:prstGeom>
-          <a:noFill/>
-          <a:ln/>
-        </p:spPr>
-        <p:txBody>
-          <a:bodyPr wrap="none" lIns="0" tIns="0" rIns="0" bIns="0" rtlCol="0" anchor="ctr"/>
-          <a:lstStyle/>
-          <a:p>
-            <a:pPr algn="l" indent="0" marL="0">
-              <a:buNone/>
-            </a:pPr>
-            <a:r>
-              <a:rPr lang="ko-KR" altLang="en-US" sz="1200" spc="-24" kern="0" dirty="0">
+              <a:t>남은 3주 내 시연 영상 완성</a:t>
+            </a:r>
+            <a:endParaRPr lang="en-US" sz="1008" dirty="0"/>
+          </a:p>
+        </p:txBody>
+      </p:sp>
+      <p:sp>
+        <p:nvSpPr>
+          <p:cNvPr id="129" name="학생 BIM 경진대회 장려상"/>
+          <p:cNvSpPr txBox="1"/>
+          <p:nvPr/>
+        </p:nvSpPr>
+        <p:spPr>
+          <a:xfrm>
+            <a:off x="3561207" y="9172194"/>
+            <a:ext cx="1401495" cy="152400"/>
+          </a:xfrm>
+          <a:prstGeom prst="rect">
+            <a:avLst/>
+          </a:prstGeom>
+          <a:noFill/>
+          <a:ln/>
+        </p:spPr>
+        <p:txBody>
+          <a:bodyPr wrap="none" lIns="0" tIns="0" rIns="0" bIns="0" rtlCol="0" anchor="ctr"/>
+          <a:lstStyle/>
+          <a:p>
+            <a:pPr algn="l" indent="0" marL="0">
+              <a:buNone/>
+            </a:pPr>
+            <a:r>
+              <a:rPr lang="ko-KR" altLang="en-US" sz="1008" spc="-20" kern="0" dirty="0">
                 <a:solidFill>
                   <a:srgbClr val="8A5A00"/>
                 </a:solidFill>
@@ -3336,44 +4999,44 @@
               </a:rPr>
               <a:t>학생 BIM 경진대회 장려상</a:t>
             </a:r>
-            <a:endParaRPr lang="en-US" sz="1200" dirty="0"/>
-          </a:p>
-        </p:txBody>
-      </p:sp>
-      <p:sp>
-        <p:nvSpPr>
-          <p:cNvPr id="76" name="3주 내 완수"/>
-          <p:cNvSpPr txBox="1"/>
-          <p:nvPr/>
-        </p:nvSpPr>
-        <p:spPr>
-          <a:xfrm>
-            <a:off x="969169" y="9139523"/>
-            <a:ext cx="548831" cy="134112"/>
-          </a:xfrm>
-          <a:prstGeom prst="rect">
-            <a:avLst/>
-          </a:prstGeom>
-          <a:noFill/>
-          <a:ln/>
-        </p:spPr>
-        <p:txBody>
-          <a:bodyPr wrap="none" lIns="0" tIns="0" rIns="0" bIns="0" rtlCol="0" anchor="ctr"/>
-          <a:lstStyle/>
-          <a:p>
-            <a:pPr algn="l" indent="0" marL="0">
-              <a:buNone/>
-            </a:pPr>
-            <a:r>
-              <a:rPr lang="ko-KR" altLang="en-US" sz="864" spc="-9" kern="0" dirty="0">
-                <a:solidFill>
-                  <a:srgbClr val="8A5A00"/>
+            <a:endParaRPr lang="en-US" sz="1008" dirty="0"/>
+          </a:p>
+        </p:txBody>
+      </p:sp>
+      <p:sp>
+        <p:nvSpPr>
+          <p:cNvPr id="130" name="KEY MESSAGE"/>
+          <p:cNvSpPr txBox="1"/>
+          <p:nvPr/>
+        </p:nvSpPr>
+        <p:spPr>
+          <a:xfrm>
+            <a:off x="1182624" y="9790557"/>
+            <a:ext cx="1065686" cy="134112"/>
+          </a:xfrm>
+          <a:prstGeom prst="rect">
+            <a:avLst/>
+          </a:prstGeom>
+          <a:noFill/>
+          <a:ln/>
+        </p:spPr>
+        <p:txBody>
+          <a:bodyPr wrap="none" lIns="0" tIns="0" rIns="0" bIns="0" rtlCol="0" anchor="ctr"/>
+          <a:lstStyle/>
+          <a:p>
+            <a:pPr algn="l" indent="0" marL="0">
+              <a:buNone/>
+            </a:pPr>
+            <a:r>
+              <a:rPr lang="ko-KR" altLang="en-US" sz="864" spc="138" kern="0" dirty="0">
+                <a:solidFill>
+                  <a:srgbClr val="8FD3F5"/>
                 </a:solidFill>
                 <a:latin typeface="Paperlogy 7 Bold" pitchFamily="34" charset="0"/>
                 <a:ea typeface="Paperlogy 7 Bold" pitchFamily="34" charset="-127"/>
                 <a:cs typeface="Paperlogy 7 Bold" pitchFamily="34" charset="-120"/>
               </a:rPr>
-              <a:t>3주 내 완수</a:t>
+              <a:t>KEY MESSAGE</a:t>
             </a:r>
             <a:endParaRPr lang="en-US" sz="864" dirty="0"/>
           </a:p>
@@ -3381,77 +5044,52 @@
       </p:sp>
       <p:sp>
         <p:nvSpPr>
-          <p:cNvPr id="77" name="KEY MESSAGE"/>
-          <p:cNvSpPr txBox="1"/>
-          <p:nvPr/>
-        </p:nvSpPr>
-        <p:spPr>
-          <a:xfrm>
-            <a:off x="1182624" y="9790557"/>
-            <a:ext cx="1065686" cy="134112"/>
-          </a:xfrm>
-          <a:prstGeom prst="rect">
-            <a:avLst/>
-          </a:prstGeom>
-          <a:noFill/>
-          <a:ln/>
-        </p:spPr>
-        <p:txBody>
-          <a:bodyPr wrap="none" lIns="0" tIns="0" rIns="0" bIns="0" rtlCol="0" anchor="ctr"/>
-          <a:lstStyle/>
-          <a:p>
-            <a:pPr algn="l" indent="0" marL="0">
-              <a:buNone/>
-            </a:pPr>
-            <a:r>
-              <a:rPr lang="ko-KR" altLang="en-US" sz="864" spc="138" kern="0" dirty="0">
-                <a:solidFill>
-                  <a:srgbClr val="8FD3F5"/>
+          <p:cNvPr id="131" name="서로 다른 사람을 하나의 공동 목표로 연결합니다"/>
+          <p:cNvSpPr txBox="1"/>
+          <p:nvPr/>
+        </p:nvSpPr>
+        <p:spPr>
+          <a:xfrm>
+            <a:off x="2358676" y="9743313"/>
+            <a:ext cx="3750951" cy="225552"/>
+          </a:xfrm>
+          <a:prstGeom prst="rect">
+            <a:avLst/>
+          </a:prstGeom>
+          <a:noFill/>
+          <a:ln/>
+        </p:spPr>
+        <p:txBody>
+          <a:bodyPr wrap="none" lIns="0" tIns="0" rIns="0" bIns="0" rtlCol="0" anchor="ctr"/>
+          <a:lstStyle/>
+          <a:p>
+            <a:pPr algn="l" indent="0" marL="0">
+              <a:buNone/>
+            </a:pPr>
+            <a:r>
+              <a:rPr lang="ko-KR" altLang="en-US" sz="1536" spc="-46" kern="0" dirty="0">
+                <a:solidFill>
+                  <a:srgbClr val="FFFFFF"/>
                 </a:solidFill>
                 <a:latin typeface="Paperlogy 7 Bold" pitchFamily="34" charset="0"/>
                 <a:ea typeface="Paperlogy 7 Bold" pitchFamily="34" charset="-127"/>
                 <a:cs typeface="Paperlogy 7 Bold" pitchFamily="34" charset="-120"/>
               </a:rPr>
-              <a:t>KEY MESSAGE</a:t>
-            </a:r>
-            <a:endParaRPr lang="en-US" sz="864" dirty="0"/>
-          </a:p>
-        </p:txBody>
-      </p:sp>
-      <p:sp>
-        <p:nvSpPr>
-          <p:cNvPr id="78" name="서로 다른 사람을 하나의 공동 목표로 연결합니다"/>
-          <p:cNvSpPr txBox="1"/>
-          <p:nvPr/>
-        </p:nvSpPr>
-        <p:spPr>
-          <a:xfrm>
-            <a:off x="2358676" y="9743313"/>
-            <a:ext cx="3750951" cy="225552"/>
-          </a:xfrm>
-          <a:prstGeom prst="rect">
-            <a:avLst/>
-          </a:prstGeom>
-          <a:noFill/>
-          <a:ln/>
-        </p:spPr>
-        <p:txBody>
-          <a:bodyPr wrap="none" lIns="0" tIns="0" rIns="0" bIns="0" rtlCol="0" anchor="ctr"/>
-          <a:lstStyle/>
-          <a:p>
+              <a:t>서로 다른 사람을 </a:t>
+            </a:r>
             <a:pPr algn="l" indent="0" marL="0">
               <a:buNone/>
             </a:pPr>
             <a:r>
               <a:rPr lang="ko-KR" altLang="en-US" sz="1536" spc="-46" kern="0" dirty="0">
                 <a:solidFill>
-                  <a:srgbClr val="FFFFFF"/>
+                  <a:srgbClr val="FDBB30"/>
                 </a:solidFill>
                 <a:latin typeface="Paperlogy 7 Bold" pitchFamily="34" charset="0"/>
                 <a:ea typeface="Paperlogy 7 Bold" pitchFamily="34" charset="-127"/>
                 <a:cs typeface="Paperlogy 7 Bold" pitchFamily="34" charset="-120"/>
               </a:rPr>
-              <a:t>서로 다른 사람을 </a:t>
+              <a:t>하나의 공동 목표</a:t>
             </a:r>
             <a:pPr algn="l" indent="0" marL="0">
               <a:buNone/>
@@ -3459,26 +5097,12 @@
             <a:r>
               <a:rPr lang="ko-KR" altLang="en-US" sz="1536" spc="-46" kern="0" dirty="0">
                 <a:solidFill>
-                  <a:srgbClr val="FDBB30"/>
+                  <a:srgbClr val="FFFFFF"/>
                 </a:solidFill>
                 <a:latin typeface="Paperlogy 7 Bold" pitchFamily="34" charset="0"/>
                 <a:ea typeface="Paperlogy 7 Bold" pitchFamily="34" charset="-127"/>
                 <a:cs typeface="Paperlogy 7 Bold" pitchFamily="34" charset="-120"/>
               </a:rPr>
-              <a:t>하나의 공동 목표</a:t>
-            </a:r>
-            <a:pPr algn="l" indent="0" marL="0">
-              <a:buNone/>
-            </a:pPr>
-            <a:r>
-              <a:rPr lang="ko-KR" altLang="en-US" sz="1536" spc="-46" kern="0" dirty="0">
-                <a:solidFill>
-                  <a:srgbClr val="FFFFFF"/>
-                </a:solidFill>
-                <a:latin typeface="Paperlogy 7 Bold" pitchFamily="34" charset="0"/>
-                <a:ea typeface="Paperlogy 7 Bold" pitchFamily="34" charset="-127"/>
-                <a:cs typeface="Paperlogy 7 Bold" pitchFamily="34" charset="-120"/>
-              </a:rPr>
               <a:t>로 연결합니다</a:t>
             </a:r>
             <a:endParaRPr lang="en-US" sz="1536" dirty="0"/>
@@ -3487,7 +5111,7 @@
       </p:sp>
       <p:sp>
         <p:nvSpPr>
-          <p:cNvPr id="79" name="2026년 하반기 신입사원 공개채용"/>
+          <p:cNvPr id="132" name="2026년 하반기 신입사원 공개채용"/>
           <p:cNvSpPr txBox="1"/>
           <p:nvPr/>
         </p:nvSpPr>
@@ -3526,7 +5150,7 @@
       </p:sp>
       <p:sp>
         <p:nvSpPr>
-          <p:cNvPr id="80" name="01 / 03"/>
+          <p:cNvPr id="133" name="01 / 03"/>
           <p:cNvSpPr txBox="1"/>
           <p:nvPr/>
         </p:nvSpPr>

</xml_diff>